<commit_message>
include challenges and update scope
</commit_message>
<xml_diff>
--- a/docs/proposal/slides.pptx
+++ b/docs/proposal/slides.pptx
@@ -31,6 +31,9 @@
     <p:sldId id="276" r:id="rId27"/>
     <p:sldId id="277" r:id="rId28"/>
     <p:sldId id="278" r:id="rId29"/>
+    <p:sldId id="279" r:id="rId30"/>
+    <p:sldId id="280" r:id="rId31"/>
+    <p:sldId id="281" r:id="rId32"/>
   </p:sldIdLst>
   <p:sldSz cy="6858000" cx="9144000"/>
   <p:notesSz cx="7315200" cy="9601200"/>
@@ -1206,7 +1209,7 @@
   <p:cSld>
     <p:spTree>
       <p:nvGrpSpPr>
-        <p:cNvPr id="160" name="Shape 160"/>
+        <p:cNvPr id="159" name="Shape 159"/>
         <p:cNvGrpSpPr/>
         <p:nvPr/>
       </p:nvGrpSpPr>
@@ -1220,7 +1223,7 @@
       </p:grpSpPr>
       <p:sp>
         <p:nvSpPr>
-          <p:cNvPr id="161" name="Google Shape;161;p10:notes"/>
+          <p:cNvPr id="160" name="Google Shape;160;p10:notes"/>
           <p:cNvSpPr txBox="1"/>
           <p:nvPr>
             <p:ph idx="1" type="body"/>
@@ -1267,7 +1270,7 @@
       </p:sp>
       <p:sp>
         <p:nvSpPr>
-          <p:cNvPr id="162" name="Google Shape;162;p10:notes"/>
+          <p:cNvPr id="161" name="Google Shape;161;p10:notes"/>
           <p:cNvSpPr/>
           <p:nvPr>
             <p:ph idx="2" type="sldImg"/>
@@ -1323,7 +1326,7 @@
   <p:cSld>
     <p:spTree>
       <p:nvGrpSpPr>
-        <p:cNvPr id="166" name="Shape 166"/>
+        <p:cNvPr id="165" name="Shape 165"/>
         <p:cNvGrpSpPr/>
         <p:nvPr/>
       </p:nvGrpSpPr>
@@ -1337,7 +1340,7 @@
       </p:grpSpPr>
       <p:sp>
         <p:nvSpPr>
-          <p:cNvPr id="167" name="Google Shape;167;p11:notes"/>
+          <p:cNvPr id="166" name="Google Shape;166;p11:notes"/>
           <p:cNvSpPr txBox="1"/>
           <p:nvPr>
             <p:ph idx="1" type="body"/>
@@ -1384,7 +1387,7 @@
       </p:sp>
       <p:sp>
         <p:nvSpPr>
-          <p:cNvPr id="168" name="Google Shape;168;p11:notes"/>
+          <p:cNvPr id="167" name="Google Shape;167;p11:notes"/>
           <p:cNvSpPr/>
           <p:nvPr>
             <p:ph idx="2" type="sldImg"/>
@@ -1440,7 +1443,7 @@
   <p:cSld>
     <p:spTree>
       <p:nvGrpSpPr>
-        <p:cNvPr id="172" name="Shape 172"/>
+        <p:cNvPr id="171" name="Shape 171"/>
         <p:cNvGrpSpPr/>
         <p:nvPr/>
       </p:nvGrpSpPr>
@@ -1454,7 +1457,7 @@
       </p:grpSpPr>
       <p:sp>
         <p:nvSpPr>
-          <p:cNvPr id="173" name="Google Shape;173;p12:notes"/>
+          <p:cNvPr id="172" name="Google Shape;172;p12:notes"/>
           <p:cNvSpPr txBox="1"/>
           <p:nvPr>
             <p:ph idx="1" type="body"/>
@@ -1501,7 +1504,7 @@
       </p:sp>
       <p:sp>
         <p:nvSpPr>
-          <p:cNvPr id="174" name="Google Shape;174;p12:notes"/>
+          <p:cNvPr id="173" name="Google Shape;173;p12:notes"/>
           <p:cNvSpPr/>
           <p:nvPr>
             <p:ph idx="2" type="sldImg"/>
@@ -1557,7 +1560,7 @@
   <p:cSld>
     <p:spTree>
       <p:nvGrpSpPr>
-        <p:cNvPr id="178" name="Shape 178"/>
+        <p:cNvPr id="177" name="Shape 177"/>
         <p:cNvGrpSpPr/>
         <p:nvPr/>
       </p:nvGrpSpPr>
@@ -1571,7 +1574,7 @@
       </p:grpSpPr>
       <p:sp>
         <p:nvSpPr>
-          <p:cNvPr id="179" name="Google Shape;179;p15:notes"/>
+          <p:cNvPr id="178" name="Google Shape;178;p15:notes"/>
           <p:cNvSpPr txBox="1"/>
           <p:nvPr>
             <p:ph idx="1" type="body"/>
@@ -1618,7 +1621,7 @@
       </p:sp>
       <p:sp>
         <p:nvSpPr>
-          <p:cNvPr id="180" name="Google Shape;180;p15:notes"/>
+          <p:cNvPr id="179" name="Google Shape;179;p15:notes"/>
           <p:cNvSpPr/>
           <p:nvPr>
             <p:ph idx="2" type="sldImg"/>
@@ -1674,7 +1677,7 @@
   <p:cSld>
     <p:spTree>
       <p:nvGrpSpPr>
-        <p:cNvPr id="187" name="Shape 187"/>
+        <p:cNvPr id="186" name="Shape 186"/>
         <p:cNvGrpSpPr/>
         <p:nvPr/>
       </p:nvGrpSpPr>
@@ -1688,7 +1691,7 @@
       </p:grpSpPr>
       <p:sp>
         <p:nvSpPr>
-          <p:cNvPr id="188" name="Google Shape;188;p13:notes"/>
+          <p:cNvPr id="187" name="Google Shape;187;p13:notes"/>
           <p:cNvSpPr txBox="1"/>
           <p:nvPr>
             <p:ph idx="1" type="body"/>
@@ -1735,7 +1738,7 @@
       </p:sp>
       <p:sp>
         <p:nvSpPr>
-          <p:cNvPr id="189" name="Google Shape;189;p13:notes"/>
+          <p:cNvPr id="188" name="Google Shape;188;p13:notes"/>
           <p:cNvSpPr/>
           <p:nvPr>
             <p:ph idx="2" type="sldImg"/>
@@ -1791,7 +1794,7 @@
   <p:cSld>
     <p:spTree>
       <p:nvGrpSpPr>
-        <p:cNvPr id="238" name="Shape 238"/>
+        <p:cNvPr id="237" name="Shape 237"/>
         <p:cNvGrpSpPr/>
         <p:nvPr/>
       </p:nvGrpSpPr>
@@ -1805,7 +1808,7 @@
       </p:grpSpPr>
       <p:sp>
         <p:nvSpPr>
-          <p:cNvPr id="239" name="Google Shape;239;p14:notes"/>
+          <p:cNvPr id="238" name="Google Shape;238;p14:notes"/>
           <p:cNvSpPr txBox="1"/>
           <p:nvPr>
             <p:ph idx="1" type="body"/>
@@ -1852,7 +1855,7 @@
       </p:sp>
       <p:sp>
         <p:nvSpPr>
-          <p:cNvPr id="240" name="Google Shape;240;p14:notes"/>
+          <p:cNvPr id="239" name="Google Shape;239;p14:notes"/>
           <p:cNvSpPr/>
           <p:nvPr>
             <p:ph idx="2" type="sldImg"/>
@@ -1908,7 +1911,7 @@
   <p:cSld>
     <p:spTree>
       <p:nvGrpSpPr>
-        <p:cNvPr id="244" name="Shape 244"/>
+        <p:cNvPr id="243" name="Shape 243"/>
         <p:cNvGrpSpPr/>
         <p:nvPr/>
       </p:nvGrpSpPr>
@@ -1922,7 +1925,7 @@
       </p:grpSpPr>
       <p:sp>
         <p:nvSpPr>
-          <p:cNvPr id="245" name="Google Shape;245;g3fa1e6576f6_0_95:notes"/>
+          <p:cNvPr id="244" name="Google Shape;244;g3fa1e6576f6_0_95:notes"/>
           <p:cNvSpPr txBox="1"/>
           <p:nvPr>
             <p:ph idx="1" type="body"/>
@@ -1969,7 +1972,7 @@
       </p:sp>
       <p:sp>
         <p:nvSpPr>
-          <p:cNvPr id="246" name="Google Shape;246;g3fa1e6576f6_0_95:notes"/>
+          <p:cNvPr id="245" name="Google Shape;245;g3fa1e6576f6_0_95:notes"/>
           <p:cNvSpPr/>
           <p:nvPr>
             <p:ph idx="2" type="sldImg"/>
@@ -2025,7 +2028,7 @@
   <p:cSld>
     <p:spTree>
       <p:nvGrpSpPr>
-        <p:cNvPr id="250" name="Shape 250"/>
+        <p:cNvPr id="249" name="Shape 249"/>
         <p:cNvGrpSpPr/>
         <p:nvPr/>
       </p:nvGrpSpPr>
@@ -2039,7 +2042,7 @@
       </p:grpSpPr>
       <p:sp>
         <p:nvSpPr>
-          <p:cNvPr id="251" name="Google Shape;251;g3fa1e6576f6_0_156:notes"/>
+          <p:cNvPr id="250" name="Google Shape;250;g3fa1e6576f6_0_156:notes"/>
           <p:cNvSpPr txBox="1"/>
           <p:nvPr>
             <p:ph idx="1" type="body"/>
@@ -2086,7 +2089,7 @@
       </p:sp>
       <p:sp>
         <p:nvSpPr>
-          <p:cNvPr id="252" name="Google Shape;252;g3fa1e6576f6_0_156:notes"/>
+          <p:cNvPr id="251" name="Google Shape;251;g3fa1e6576f6_0_156:notes"/>
           <p:cNvSpPr/>
           <p:nvPr>
             <p:ph idx="2" type="sldImg"/>
@@ -2259,7 +2262,7 @@
   <p:cSld>
     <p:spTree>
       <p:nvGrpSpPr>
-        <p:cNvPr id="256" name="Shape 256"/>
+        <p:cNvPr id="255" name="Shape 255"/>
         <p:cNvGrpSpPr/>
         <p:nvPr/>
       </p:nvGrpSpPr>
@@ -2273,7 +2276,7 @@
       </p:grpSpPr>
       <p:sp>
         <p:nvSpPr>
-          <p:cNvPr id="257" name="Google Shape;257;p17:notes"/>
+          <p:cNvPr id="256" name="Google Shape;256;p17:notes"/>
           <p:cNvSpPr txBox="1"/>
           <p:nvPr>
             <p:ph idx="1" type="body"/>
@@ -2320,7 +2323,7 @@
       </p:sp>
       <p:sp>
         <p:nvSpPr>
-          <p:cNvPr id="258" name="Google Shape;258;p17:notes"/>
+          <p:cNvPr id="257" name="Google Shape;257;p17:notes"/>
           <p:cNvSpPr/>
           <p:nvPr>
             <p:ph idx="2" type="sldImg"/>
@@ -2376,7 +2379,7 @@
   <p:cSld>
     <p:spTree>
       <p:nvGrpSpPr>
-        <p:cNvPr id="262" name="Shape 262"/>
+        <p:cNvPr id="261" name="Shape 261"/>
         <p:cNvGrpSpPr/>
         <p:nvPr/>
       </p:nvGrpSpPr>
@@ -2390,7 +2393,7 @@
       </p:grpSpPr>
       <p:sp>
         <p:nvSpPr>
-          <p:cNvPr id="263" name="Google Shape;263;g3fa1e6576f6_0_163:notes"/>
+          <p:cNvPr id="262" name="Google Shape;262;g3fa40b541af_0_3:notes"/>
           <p:cNvSpPr txBox="1"/>
           <p:nvPr>
             <p:ph idx="1" type="body"/>
@@ -2437,7 +2440,7 @@
       </p:sp>
       <p:sp>
         <p:nvSpPr>
-          <p:cNvPr id="264" name="Google Shape;264;g3fa1e6576f6_0_163:notes"/>
+          <p:cNvPr id="263" name="Google Shape;263;g3fa40b541af_0_3:notes"/>
           <p:cNvSpPr/>
           <p:nvPr>
             <p:ph idx="2" type="sldImg"/>
@@ -2493,7 +2496,7 @@
   <p:cSld>
     <p:spTree>
       <p:nvGrpSpPr>
-        <p:cNvPr id="268" name="Shape 268"/>
+        <p:cNvPr id="267" name="Shape 267"/>
         <p:cNvGrpSpPr/>
         <p:nvPr/>
       </p:nvGrpSpPr>
@@ -2507,7 +2510,241 @@
       </p:grpSpPr>
       <p:sp>
         <p:nvSpPr>
-          <p:cNvPr id="269" name="Google Shape;269;p16:notes"/>
+          <p:cNvPr id="268" name="Google Shape;268;g3fa40b541af_0_8:notes"/>
+          <p:cNvSpPr txBox="1"/>
+          <p:nvPr>
+            <p:ph idx="1" type="body"/>
+          </p:nvPr>
+        </p:nvSpPr>
+        <p:spPr>
+          <a:xfrm>
+            <a:off x="731500" y="4560550"/>
+            <a:ext cx="5852100" cy="4320600"/>
+          </a:xfrm>
+          <a:prstGeom prst="rect">
+            <a:avLst/>
+          </a:prstGeom>
+          <a:noFill/>
+          <a:ln>
+            <a:noFill/>
+          </a:ln>
+        </p:spPr>
+        <p:txBody>
+          <a:bodyPr anchorCtr="0" anchor="t" bIns="91425" lIns="91425" spcFirstLastPara="1" rIns="91425" wrap="square" tIns="91425">
+            <a:noAutofit/>
+          </a:bodyPr>
+          <a:lstStyle/>
+          <a:p>
+            <a:pPr indent="0" lvl="0" marL="0" rtl="0" algn="l">
+              <a:lnSpc>
+                <a:spcPct val="100000"/>
+              </a:lnSpc>
+              <a:spcBef>
+                <a:spcPts val="0"/>
+              </a:spcBef>
+              <a:spcAft>
+                <a:spcPts val="0"/>
+              </a:spcAft>
+              <a:buSzPts val="1100"/>
+              <a:buNone/>
+            </a:pPr>
+            <a:r>
+              <a:t/>
+            </a:r>
+            <a:endParaRPr/>
+          </a:p>
+        </p:txBody>
+      </p:sp>
+      <p:sp>
+        <p:nvSpPr>
+          <p:cNvPr id="269" name="Google Shape;269;g3fa40b541af_0_8:notes"/>
+          <p:cNvSpPr/>
+          <p:nvPr>
+            <p:ph idx="2" type="sldImg"/>
+          </p:nvPr>
+        </p:nvSpPr>
+        <p:spPr>
+          <a:xfrm>
+            <a:off x="1257300" y="720725"/>
+            <a:ext cx="4800600" cy="3600600"/>
+          </a:xfrm>
+          <a:custGeom>
+            <a:rect b="b" l="l" r="r" t="t"/>
+            <a:pathLst>
+              <a:path extrusionOk="0" h="120000" w="120000">
+                <a:moveTo>
+                  <a:pt x="0" y="0"/>
+                </a:moveTo>
+                <a:lnTo>
+                  <a:pt x="120000" y="0"/>
+                </a:lnTo>
+                <a:lnTo>
+                  <a:pt x="120000" y="120000"/>
+                </a:lnTo>
+                <a:lnTo>
+                  <a:pt x="0" y="120000"/>
+                </a:lnTo>
+                <a:close/>
+              </a:path>
+            </a:pathLst>
+          </a:custGeom>
+          <a:noFill/>
+          <a:ln cap="flat" cmpd="sng" w="9525">
+            <a:solidFill>
+              <a:srgbClr val="000000"/>
+            </a:solidFill>
+            <a:prstDash val="solid"/>
+            <a:round/>
+            <a:headEnd len="sm" w="sm" type="none"/>
+            <a:tailEnd len="sm" w="sm" type="none"/>
+          </a:ln>
+        </p:spPr>
+      </p:sp>
+    </p:spTree>
+  </p:cSld>
+  <p:clrMapOvr>
+    <a:masterClrMapping/>
+  </p:clrMapOvr>
+</p:notes>
+</file>
+
+<file path=ppt/notesSlides/notesSlide23.xml><?xml version="1.0" encoding="utf-8"?>
+<p:notes xmlns:a="http://schemas.openxmlformats.org/drawingml/2006/main" xmlns:r="http://schemas.openxmlformats.org/officeDocument/2006/relationships" xmlns:mc="http://schemas.openxmlformats.org/markup-compatibility/2006" xmlns:mv="urn:schemas-microsoft-com:mac:vml" xmlns:p="http://schemas.openxmlformats.org/presentationml/2006/main" xmlns:c="http://schemas.openxmlformats.org/drawingml/2006/chart" xmlns:dgm="http://schemas.openxmlformats.org/drawingml/2006/diagram" xmlns:o="urn:schemas-microsoft-com:office:office" xmlns:v="urn:schemas-microsoft-com:vml" xmlns:pvml="urn:schemas-microsoft-com:office:powerpoint" xmlns:com="http://schemas.openxmlformats.org/drawingml/2006/compatibility" xmlns:p14="http://schemas.microsoft.com/office/powerpoint/2010/main" xmlns:p15="http://schemas.microsoft.com/office/powerpoint/2012/main" xmlns:ahyp="http://schemas.microsoft.com/office/drawing/2018/hyperlinkcolor" showMasterPhAnim="0" showMasterSp="0">
+  <p:cSld>
+    <p:spTree>
+      <p:nvGrpSpPr>
+        <p:cNvPr id="273" name="Shape 273"/>
+        <p:cNvGrpSpPr/>
+        <p:nvPr/>
+      </p:nvGrpSpPr>
+      <p:grpSpPr>
+        <a:xfrm>
+          <a:off x="0" y="0"/>
+          <a:ext cx="0" cy="0"/>
+          <a:chOff x="0" y="0"/>
+          <a:chExt cx="0" cy="0"/>
+        </a:xfrm>
+      </p:grpSpPr>
+      <p:sp>
+        <p:nvSpPr>
+          <p:cNvPr id="274" name="Google Shape;274;g3fa1e6576f6_0_163:notes"/>
+          <p:cNvSpPr txBox="1"/>
+          <p:nvPr>
+            <p:ph idx="1" type="body"/>
+          </p:nvPr>
+        </p:nvSpPr>
+        <p:spPr>
+          <a:xfrm>
+            <a:off x="731500" y="4560550"/>
+            <a:ext cx="5852100" cy="4320600"/>
+          </a:xfrm>
+          <a:prstGeom prst="rect">
+            <a:avLst/>
+          </a:prstGeom>
+          <a:noFill/>
+          <a:ln>
+            <a:noFill/>
+          </a:ln>
+        </p:spPr>
+        <p:txBody>
+          <a:bodyPr anchorCtr="0" anchor="t" bIns="91425" lIns="91425" spcFirstLastPara="1" rIns="91425" wrap="square" tIns="91425">
+            <a:noAutofit/>
+          </a:bodyPr>
+          <a:lstStyle/>
+          <a:p>
+            <a:pPr indent="0" lvl="0" marL="0" rtl="0" algn="l">
+              <a:lnSpc>
+                <a:spcPct val="100000"/>
+              </a:lnSpc>
+              <a:spcBef>
+                <a:spcPts val="0"/>
+              </a:spcBef>
+              <a:spcAft>
+                <a:spcPts val="0"/>
+              </a:spcAft>
+              <a:buSzPts val="1100"/>
+              <a:buNone/>
+            </a:pPr>
+            <a:r>
+              <a:t/>
+            </a:r>
+            <a:endParaRPr/>
+          </a:p>
+        </p:txBody>
+      </p:sp>
+      <p:sp>
+        <p:nvSpPr>
+          <p:cNvPr id="275" name="Google Shape;275;g3fa1e6576f6_0_163:notes"/>
+          <p:cNvSpPr/>
+          <p:nvPr>
+            <p:ph idx="2" type="sldImg"/>
+          </p:nvPr>
+        </p:nvSpPr>
+        <p:spPr>
+          <a:xfrm>
+            <a:off x="1257300" y="720725"/>
+            <a:ext cx="4800600" cy="3600600"/>
+          </a:xfrm>
+          <a:custGeom>
+            <a:rect b="b" l="l" r="r" t="t"/>
+            <a:pathLst>
+              <a:path extrusionOk="0" h="120000" w="120000">
+                <a:moveTo>
+                  <a:pt x="0" y="0"/>
+                </a:moveTo>
+                <a:lnTo>
+                  <a:pt x="120000" y="0"/>
+                </a:lnTo>
+                <a:lnTo>
+                  <a:pt x="120000" y="120000"/>
+                </a:lnTo>
+                <a:lnTo>
+                  <a:pt x="0" y="120000"/>
+                </a:lnTo>
+                <a:close/>
+              </a:path>
+            </a:pathLst>
+          </a:custGeom>
+          <a:noFill/>
+          <a:ln cap="flat" cmpd="sng" w="9525">
+            <a:solidFill>
+              <a:srgbClr val="000000"/>
+            </a:solidFill>
+            <a:prstDash val="solid"/>
+            <a:round/>
+            <a:headEnd len="sm" w="sm" type="none"/>
+            <a:tailEnd len="sm" w="sm" type="none"/>
+          </a:ln>
+        </p:spPr>
+      </p:sp>
+    </p:spTree>
+  </p:cSld>
+  <p:clrMapOvr>
+    <a:masterClrMapping/>
+  </p:clrMapOvr>
+</p:notes>
+</file>
+
+<file path=ppt/notesSlides/notesSlide24.xml><?xml version="1.0" encoding="utf-8"?>
+<p:notes xmlns:a="http://schemas.openxmlformats.org/drawingml/2006/main" xmlns:r="http://schemas.openxmlformats.org/officeDocument/2006/relationships" xmlns:mc="http://schemas.openxmlformats.org/markup-compatibility/2006" xmlns:mv="urn:schemas-microsoft-com:mac:vml" xmlns:p="http://schemas.openxmlformats.org/presentationml/2006/main" xmlns:c="http://schemas.openxmlformats.org/drawingml/2006/chart" xmlns:dgm="http://schemas.openxmlformats.org/drawingml/2006/diagram" xmlns:o="urn:schemas-microsoft-com:office:office" xmlns:v="urn:schemas-microsoft-com:vml" xmlns:pvml="urn:schemas-microsoft-com:office:powerpoint" xmlns:com="http://schemas.openxmlformats.org/drawingml/2006/compatibility" xmlns:p14="http://schemas.microsoft.com/office/powerpoint/2010/main" xmlns:p15="http://schemas.microsoft.com/office/powerpoint/2012/main" xmlns:ahyp="http://schemas.microsoft.com/office/drawing/2018/hyperlinkcolor" showMasterPhAnim="0" showMasterSp="0">
+  <p:cSld>
+    <p:spTree>
+      <p:nvGrpSpPr>
+        <p:cNvPr id="279" name="Shape 279"/>
+        <p:cNvGrpSpPr/>
+        <p:nvPr/>
+      </p:nvGrpSpPr>
+      <p:grpSpPr>
+        <a:xfrm>
+          <a:off x="0" y="0"/>
+          <a:ext cx="0" cy="0"/>
+          <a:chOff x="0" y="0"/>
+          <a:chExt cx="0" cy="0"/>
+        </a:xfrm>
+      </p:grpSpPr>
+      <p:sp>
+        <p:nvSpPr>
+          <p:cNvPr id="280" name="Google Shape;280;p16:notes"/>
           <p:cNvSpPr txBox="1"/>
           <p:nvPr>
             <p:ph idx="1" type="body"/>
@@ -2554,7 +2791,7 @@
       </p:sp>
       <p:sp>
         <p:nvSpPr>
-          <p:cNvPr id="270" name="Google Shape;270;p16:notes"/>
+          <p:cNvPr id="281" name="Google Shape;281;p16:notes"/>
           <p:cNvSpPr/>
           <p:nvPr>
             <p:ph idx="2" type="sldImg"/>
@@ -2605,12 +2842,12 @@
 </p:notes>
 </file>
 
-<file path=ppt/notesSlides/notesSlide23.xml><?xml version="1.0" encoding="utf-8"?>
+<file path=ppt/notesSlides/notesSlide25.xml><?xml version="1.0" encoding="utf-8"?>
 <p:notes xmlns:a="http://schemas.openxmlformats.org/drawingml/2006/main" xmlns:r="http://schemas.openxmlformats.org/officeDocument/2006/relationships" xmlns:mc="http://schemas.openxmlformats.org/markup-compatibility/2006" xmlns:mv="urn:schemas-microsoft-com:mac:vml" xmlns:p="http://schemas.openxmlformats.org/presentationml/2006/main" xmlns:c="http://schemas.openxmlformats.org/drawingml/2006/chart" xmlns:dgm="http://schemas.openxmlformats.org/drawingml/2006/diagram" xmlns:o="urn:schemas-microsoft-com:office:office" xmlns:v="urn:schemas-microsoft-com:vml" xmlns:pvml="urn:schemas-microsoft-com:office:powerpoint" xmlns:com="http://schemas.openxmlformats.org/drawingml/2006/compatibility" xmlns:p14="http://schemas.microsoft.com/office/powerpoint/2010/main" xmlns:p15="http://schemas.microsoft.com/office/powerpoint/2012/main" xmlns:ahyp="http://schemas.microsoft.com/office/drawing/2018/hyperlinkcolor" showMasterPhAnim="0" showMasterSp="0">
   <p:cSld>
     <p:spTree>
       <p:nvGrpSpPr>
-        <p:cNvPr id="274" name="Shape 274"/>
+        <p:cNvPr id="285" name="Shape 285"/>
         <p:cNvGrpSpPr/>
         <p:nvPr/>
       </p:nvGrpSpPr>
@@ -2624,7 +2861,7 @@
       </p:grpSpPr>
       <p:sp>
         <p:nvSpPr>
-          <p:cNvPr id="275" name="Google Shape;275;g3fa1e6576f6_0_107:notes"/>
+          <p:cNvPr id="286" name="Google Shape;286;g3fa1e6576f6_0_107:notes"/>
           <p:cNvSpPr txBox="1"/>
           <p:nvPr>
             <p:ph idx="1" type="body"/>
@@ -2671,7 +2908,124 @@
       </p:sp>
       <p:sp>
         <p:nvSpPr>
-          <p:cNvPr id="276" name="Google Shape;276;g3fa1e6576f6_0_107:notes"/>
+          <p:cNvPr id="287" name="Google Shape;287;g3fa1e6576f6_0_107:notes"/>
+          <p:cNvSpPr/>
+          <p:nvPr>
+            <p:ph idx="2" type="sldImg"/>
+          </p:nvPr>
+        </p:nvSpPr>
+        <p:spPr>
+          <a:xfrm>
+            <a:off x="1257300" y="720725"/>
+            <a:ext cx="4800600" cy="3600600"/>
+          </a:xfrm>
+          <a:custGeom>
+            <a:rect b="b" l="l" r="r" t="t"/>
+            <a:pathLst>
+              <a:path extrusionOk="0" h="120000" w="120000">
+                <a:moveTo>
+                  <a:pt x="0" y="0"/>
+                </a:moveTo>
+                <a:lnTo>
+                  <a:pt x="120000" y="0"/>
+                </a:lnTo>
+                <a:lnTo>
+                  <a:pt x="120000" y="120000"/>
+                </a:lnTo>
+                <a:lnTo>
+                  <a:pt x="0" y="120000"/>
+                </a:lnTo>
+                <a:close/>
+              </a:path>
+            </a:pathLst>
+          </a:custGeom>
+          <a:noFill/>
+          <a:ln cap="flat" cmpd="sng" w="9525">
+            <a:solidFill>
+              <a:srgbClr val="000000"/>
+            </a:solidFill>
+            <a:prstDash val="solid"/>
+            <a:round/>
+            <a:headEnd len="sm" w="sm" type="none"/>
+            <a:tailEnd len="sm" w="sm" type="none"/>
+          </a:ln>
+        </p:spPr>
+      </p:sp>
+    </p:spTree>
+  </p:cSld>
+  <p:clrMapOvr>
+    <a:masterClrMapping/>
+  </p:clrMapOvr>
+</p:notes>
+</file>
+
+<file path=ppt/notesSlides/notesSlide26.xml><?xml version="1.0" encoding="utf-8"?>
+<p:notes xmlns:a="http://schemas.openxmlformats.org/drawingml/2006/main" xmlns:r="http://schemas.openxmlformats.org/officeDocument/2006/relationships" xmlns:mc="http://schemas.openxmlformats.org/markup-compatibility/2006" xmlns:mv="urn:schemas-microsoft-com:mac:vml" xmlns:p="http://schemas.openxmlformats.org/presentationml/2006/main" xmlns:c="http://schemas.openxmlformats.org/drawingml/2006/chart" xmlns:dgm="http://schemas.openxmlformats.org/drawingml/2006/diagram" xmlns:o="urn:schemas-microsoft-com:office:office" xmlns:v="urn:schemas-microsoft-com:vml" xmlns:pvml="urn:schemas-microsoft-com:office:powerpoint" xmlns:com="http://schemas.openxmlformats.org/drawingml/2006/compatibility" xmlns:p14="http://schemas.microsoft.com/office/powerpoint/2010/main" xmlns:p15="http://schemas.microsoft.com/office/powerpoint/2012/main" xmlns:ahyp="http://schemas.microsoft.com/office/drawing/2018/hyperlinkcolor" showMasterPhAnim="0" showMasterSp="0">
+  <p:cSld>
+    <p:spTree>
+      <p:nvGrpSpPr>
+        <p:cNvPr id="291" name="Shape 291"/>
+        <p:cNvGrpSpPr/>
+        <p:nvPr/>
+      </p:nvGrpSpPr>
+      <p:grpSpPr>
+        <a:xfrm>
+          <a:off x="0" y="0"/>
+          <a:ext cx="0" cy="0"/>
+          <a:chOff x="0" y="0"/>
+          <a:chExt cx="0" cy="0"/>
+        </a:xfrm>
+      </p:grpSpPr>
+      <p:sp>
+        <p:nvSpPr>
+          <p:cNvPr id="292" name="Google Shape;292;g3fa40b541af_0_19:notes"/>
+          <p:cNvSpPr txBox="1"/>
+          <p:nvPr>
+            <p:ph idx="1" type="body"/>
+          </p:nvPr>
+        </p:nvSpPr>
+        <p:spPr>
+          <a:xfrm>
+            <a:off x="731500" y="4560550"/>
+            <a:ext cx="5852100" cy="4320600"/>
+          </a:xfrm>
+          <a:prstGeom prst="rect">
+            <a:avLst/>
+          </a:prstGeom>
+          <a:noFill/>
+          <a:ln>
+            <a:noFill/>
+          </a:ln>
+        </p:spPr>
+        <p:txBody>
+          <a:bodyPr anchorCtr="0" anchor="t" bIns="91425" lIns="91425" spcFirstLastPara="1" rIns="91425" wrap="square" tIns="91425">
+            <a:noAutofit/>
+          </a:bodyPr>
+          <a:lstStyle/>
+          <a:p>
+            <a:pPr indent="0" lvl="0" marL="0" rtl="0" algn="l">
+              <a:lnSpc>
+                <a:spcPct val="100000"/>
+              </a:lnSpc>
+              <a:spcBef>
+                <a:spcPts val="0"/>
+              </a:spcBef>
+              <a:spcAft>
+                <a:spcPts val="0"/>
+              </a:spcAft>
+              <a:buSzPts val="1100"/>
+              <a:buNone/>
+            </a:pPr>
+            <a:r>
+              <a:t/>
+            </a:r>
+            <a:endParaRPr/>
+          </a:p>
+        </p:txBody>
+      </p:sp>
+      <p:sp>
+        <p:nvSpPr>
+          <p:cNvPr id="293" name="Google Shape;293;g3fa40b541af_0_19:notes"/>
           <p:cNvSpPr/>
           <p:nvPr>
             <p:ph idx="2" type="sldImg"/>
@@ -16767,10 +17121,10 @@
               <a:buNone/>
             </a:pPr>
             <a:r>
-              <a:rPr lang="en-US" sz="1400"/>
+              <a:rPr lang="en-US" sz="1600"/>
               <a:t>Supervised By: M. Islam Abbasi (Lecturer)</a:t>
             </a:r>
-            <a:endParaRPr/>
+            <a:endParaRPr sz="3400"/>
           </a:p>
         </p:txBody>
       </p:sp>
@@ -16906,7 +17260,7 @@
           </a:bodyPr>
           <a:lstStyle/>
           <a:p>
-            <a:pPr indent="0" lvl="0" marL="0" rtl="0" algn="l">
+            <a:pPr indent="0" lvl="0" marL="0" rtl="0" algn="just">
               <a:lnSpc>
                 <a:spcPct val="150000"/>
               </a:lnSpc>
@@ -16986,7 +17340,7 @@
           </a:bodyPr>
           <a:lstStyle/>
           <a:p>
-            <a:pPr indent="0" lvl="0" marL="0" rtl="0" algn="l">
+            <a:pPr indent="0" lvl="0" marL="0" rtl="0" algn="just">
               <a:lnSpc>
                 <a:spcPct val="150000"/>
               </a:lnSpc>
@@ -17064,7 +17418,7 @@
           </a:bodyPr>
           <a:lstStyle/>
           <a:p>
-            <a:pPr indent="0" lvl="0" marL="0" rtl="0" algn="l">
+            <a:pPr indent="0" lvl="0" marL="0" rtl="0" algn="just">
               <a:lnSpc>
                 <a:spcPct val="150000"/>
               </a:lnSpc>
@@ -17414,7 +17768,7 @@
           </a:bodyPr>
           <a:lstStyle/>
           <a:p>
-            <a:pPr indent="0" lvl="0" marL="0" rtl="0" algn="l">
+            <a:pPr indent="0" lvl="0" marL="0" rtl="0" algn="just">
               <a:lnSpc>
                 <a:spcPct val="150000"/>
               </a:lnSpc>
@@ -17477,7 +17831,7 @@
         </p:nvSpPr>
         <p:spPr>
           <a:xfrm>
-            <a:off x="478325" y="2329774"/>
+            <a:off x="478325" y="2471664"/>
             <a:ext cx="8208600" cy="1383000"/>
           </a:xfrm>
           <a:prstGeom prst="rect">
@@ -17494,7 +17848,7 @@
           </a:bodyPr>
           <a:lstStyle/>
           <a:p>
-            <a:pPr indent="0" lvl="0" marL="0" rtl="0" algn="l">
+            <a:pPr indent="0" lvl="0" marL="0" rtl="0" algn="just">
               <a:lnSpc>
                 <a:spcPct val="150000"/>
               </a:lnSpc>
@@ -17576,7 +17930,7 @@
         </p:nvSpPr>
         <p:spPr>
           <a:xfrm>
-            <a:off x="479662" y="3695959"/>
+            <a:off x="479662" y="3944266"/>
             <a:ext cx="8229600" cy="1311000"/>
           </a:xfrm>
           <a:prstGeom prst="rect">
@@ -17593,7 +17947,7 @@
           </a:bodyPr>
           <a:lstStyle/>
           <a:p>
-            <a:pPr indent="0" lvl="0" marL="0" rtl="0" algn="l">
+            <a:pPr indent="0" lvl="0" marL="0" rtl="0" algn="just">
               <a:lnSpc>
                 <a:spcPct val="150000"/>
               </a:lnSpc>
@@ -17664,83 +18018,6 @@
               <a:cs typeface="Calibri"/>
               <a:sym typeface="Calibri"/>
             </a:endParaRPr>
-          </a:p>
-        </p:txBody>
-      </p:sp>
-      <p:sp>
-        <p:nvSpPr>
-          <p:cNvPr id="159" name="Google Shape;159;p23"/>
-          <p:cNvSpPr txBox="1"/>
-          <p:nvPr>
-            <p:ph idx="1" type="body"/>
-          </p:nvPr>
-        </p:nvSpPr>
-        <p:spPr>
-          <a:xfrm>
-            <a:off x="457200" y="5055376"/>
-            <a:ext cx="8229600" cy="941400"/>
-          </a:xfrm>
-          <a:prstGeom prst="rect">
-            <a:avLst/>
-          </a:prstGeom>
-          <a:noFill/>
-          <a:ln>
-            <a:noFill/>
-          </a:ln>
-        </p:spPr>
-        <p:txBody>
-          <a:bodyPr anchorCtr="0" anchor="t" bIns="45700" lIns="91425" spcFirstLastPara="1" rIns="91425" wrap="square" tIns="45700">
-            <a:noAutofit/>
-          </a:bodyPr>
-          <a:lstStyle/>
-          <a:p>
-            <a:pPr indent="0" lvl="0" marL="0" rtl="0" algn="l">
-              <a:lnSpc>
-                <a:spcPct val="150000"/>
-              </a:lnSpc>
-              <a:spcBef>
-                <a:spcPts val="1200"/>
-              </a:spcBef>
-              <a:spcAft>
-                <a:spcPts val="0"/>
-              </a:spcAft>
-              <a:buClr>
-                <a:schemeClr val="dk1"/>
-              </a:buClr>
-              <a:buSzPts val="1100"/>
-              <a:buNone/>
-            </a:pPr>
-            <a:r>
-              <a:rPr b="1" lang="en-US" sz="2000"/>
-              <a:t>7. No patient-facing output.</a:t>
-            </a:r>
-            <a:r>
-              <a:rPr lang="en-US" sz="2000"/>
-              <a:t> Systems stop at a label (Asare et al.) or a technical SHAP map (iMES), not a report a patient can read.</a:t>
-            </a:r>
-            <a:endParaRPr b="1" sz="2000"/>
-          </a:p>
-          <a:p>
-            <a:pPr indent="-139700" lvl="0" marL="342900" rtl="0" algn="l">
-              <a:lnSpc>
-                <a:spcPct val="150000"/>
-              </a:lnSpc>
-              <a:spcBef>
-                <a:spcPts val="1200"/>
-              </a:spcBef>
-              <a:spcAft>
-                <a:spcPts val="0"/>
-              </a:spcAft>
-              <a:buClr>
-                <a:schemeClr val="dk1"/>
-              </a:buClr>
-              <a:buSzPts val="3200"/>
-              <a:buNone/>
-            </a:pPr>
-            <a:r>
-              <a:t/>
-            </a:r>
-            <a:endParaRPr sz="1800"/>
           </a:p>
         </p:txBody>
       </p:sp>
@@ -17916,59 +18193,6 @@
                       </p:childTnLst>
                     </p:cTn>
                   </p:par>
-                  <p:par>
-                    <p:cTn fill="hold">
-                      <p:stCondLst>
-                        <p:cond delay="indefinite"/>
-                      </p:stCondLst>
-                      <p:childTnLst>
-                        <p:par>
-                          <p:cTn fill="hold">
-                            <p:stCondLst>
-                              <p:cond delay="0"/>
-                            </p:stCondLst>
-                            <p:childTnLst>
-                              <p:par>
-                                <p:cTn fill="hold" nodeType="clickEffect" presetClass="entr" presetID="10" presetSubtype="0">
-                                  <p:stCondLst>
-                                    <p:cond delay="0"/>
-                                  </p:stCondLst>
-                                  <p:childTnLst>
-                                    <p:set>
-                                      <p:cBhvr>
-                                        <p:cTn dur="1" fill="hold">
-                                          <p:stCondLst>
-                                            <p:cond delay="0"/>
-                                          </p:stCondLst>
-                                        </p:cTn>
-                                        <p:tgtEl>
-                                          <p:spTgt spid="159"/>
-                                        </p:tgtEl>
-                                        <p:attrNameLst>
-                                          <p:attrName>style.visibility</p:attrName>
-                                        </p:attrNameLst>
-                                      </p:cBhvr>
-                                      <p:to>
-                                        <p:strVal val="visible"/>
-                                      </p:to>
-                                    </p:set>
-                                    <p:animEffect filter="fade" transition="in">
-                                      <p:cBhvr>
-                                        <p:cTn dur="1000"/>
-                                        <p:tgtEl>
-                                          <p:spTgt spid="159"/>
-                                        </p:tgtEl>
-                                      </p:cBhvr>
-                                    </p:animEffect>
-                                  </p:childTnLst>
-                                </p:cTn>
-                              </p:par>
-                            </p:childTnLst>
-                          </p:cTn>
-                        </p:par>
-                      </p:childTnLst>
-                    </p:cTn>
-                  </p:par>
                 </p:childTnLst>
               </p:cTn>
               <p:prevCondLst>
@@ -17999,7 +18223,7 @@
   <p:cSld>
     <p:spTree>
       <p:nvGrpSpPr>
-        <p:cNvPr id="163" name="Shape 163"/>
+        <p:cNvPr id="162" name="Shape 162"/>
         <p:cNvGrpSpPr/>
         <p:nvPr/>
       </p:nvGrpSpPr>
@@ -18013,7 +18237,7 @@
       </p:grpSpPr>
       <p:sp>
         <p:nvSpPr>
-          <p:cNvPr id="164" name="Google Shape;164;p24"/>
+          <p:cNvPr id="163" name="Google Shape;163;p24"/>
           <p:cNvSpPr txBox="1"/>
           <p:nvPr>
             <p:ph type="title"/>
@@ -18069,7 +18293,7 @@
       </p:sp>
       <p:sp>
         <p:nvSpPr>
-          <p:cNvPr id="165" name="Google Shape;165;p24"/>
+          <p:cNvPr id="164" name="Google Shape;164;p24"/>
           <p:cNvSpPr txBox="1"/>
           <p:nvPr>
             <p:ph idx="1" type="body"/>
@@ -18131,7 +18355,7 @@
   <p:cSld>
     <p:spTree>
       <p:nvGrpSpPr>
-        <p:cNvPr id="169" name="Shape 169"/>
+        <p:cNvPr id="168" name="Shape 168"/>
         <p:cNvGrpSpPr/>
         <p:nvPr/>
       </p:nvGrpSpPr>
@@ -18145,7 +18369,7 @@
       </p:grpSpPr>
       <p:sp>
         <p:nvSpPr>
-          <p:cNvPr id="170" name="Google Shape;170;p25"/>
+          <p:cNvPr id="169" name="Google Shape;169;p25"/>
           <p:cNvSpPr txBox="1"/>
           <p:nvPr>
             <p:ph type="title"/>
@@ -18198,13 +18422,13 @@
       </p:sp>
       <p:sp>
         <p:nvSpPr>
-          <p:cNvPr id="171" name="Google Shape;171;p25"/>
+          <p:cNvPr id="170" name="Google Shape;170;p25"/>
           <p:cNvSpPr txBox="1"/>
           <p:nvPr/>
         </p:nvSpPr>
         <p:spPr>
           <a:xfrm>
-            <a:off x="774200" y="1501325"/>
+            <a:off x="413253" y="1501325"/>
             <a:ext cx="7912500" cy="4268700"/>
           </a:xfrm>
           <a:prstGeom prst="rect">
@@ -18221,7 +18445,7 @@
           </a:bodyPr>
           <a:lstStyle/>
           <a:p>
-            <a:pPr indent="-139700" lvl="0" marL="342900" rtl="0" algn="l">
+            <a:pPr indent="-139700" lvl="0" marL="342900" rtl="0" algn="just">
               <a:spcBef>
                 <a:spcPts val="0"/>
               </a:spcBef>
@@ -18240,7 +18464,7 @@
                 <a:cs typeface="Calibri"/>
                 <a:sym typeface="Calibri"/>
               </a:rPr>
-              <a:t>  Systemic diseases often show early visible signs on body surfaces such as the oral cavity, nails, eyes, tongue, and palms, but no existing tool screens for them together. Current approaches work on a single surface at a time, require dedicated capture hardware, or return a result with no confidence score and no explanation. As a result, patients without easy access to a clinician have no reliable way to self-screen using only a device they already own.</a:t>
+              <a:t> Systemic diseases often show early visible signs on body surfaces such as the oral cavity, nails, eyes, tongue, and palms, but no existing tool screens for them together. Current approaches work on a single surface at a time, require dedicated capture hardware, or return a result with no confidence score and no explanation. As a result, patients without easy access to a clinician have no reliable way to self-screen using only a device they already own.</a:t>
             </a:r>
             <a:endParaRPr sz="3200">
               <a:solidFill>
@@ -18267,7 +18491,7 @@
   <p:cSld>
     <p:spTree>
       <p:nvGrpSpPr>
-        <p:cNvPr id="175" name="Shape 175"/>
+        <p:cNvPr id="174" name="Shape 174"/>
         <p:cNvGrpSpPr/>
         <p:nvPr/>
       </p:nvGrpSpPr>
@@ -18281,7 +18505,7 @@
       </p:grpSpPr>
       <p:sp>
         <p:nvSpPr>
-          <p:cNvPr id="176" name="Google Shape;176;p26"/>
+          <p:cNvPr id="175" name="Google Shape;175;p26"/>
           <p:cNvSpPr txBox="1"/>
           <p:nvPr>
             <p:ph type="title"/>
@@ -18337,7 +18561,7 @@
       </p:sp>
       <p:sp>
         <p:nvSpPr>
-          <p:cNvPr id="177" name="Google Shape;177;p26"/>
+          <p:cNvPr id="176" name="Google Shape;176;p26"/>
           <p:cNvSpPr txBox="1"/>
           <p:nvPr>
             <p:ph idx="1" type="body"/>
@@ -18399,7 +18623,7 @@
   <p:cSld>
     <p:spTree>
       <p:nvGrpSpPr>
-        <p:cNvPr id="181" name="Shape 181"/>
+        <p:cNvPr id="180" name="Shape 180"/>
         <p:cNvGrpSpPr/>
         <p:nvPr/>
       </p:nvGrpSpPr>
@@ -18413,7 +18637,7 @@
       </p:grpSpPr>
       <p:sp>
         <p:nvSpPr>
-          <p:cNvPr id="182" name="Google Shape;182;p27"/>
+          <p:cNvPr id="181" name="Google Shape;181;p27"/>
           <p:cNvSpPr txBox="1"/>
           <p:nvPr>
             <p:ph type="title"/>
@@ -18470,7 +18694,7 @@
       </p:sp>
       <p:sp>
         <p:nvSpPr>
-          <p:cNvPr id="183" name="Google Shape;183;p27"/>
+          <p:cNvPr id="182" name="Google Shape;182;p27"/>
           <p:cNvSpPr txBox="1"/>
           <p:nvPr>
             <p:ph idx="1" type="body"/>
@@ -18495,7 +18719,7 @@
           </a:bodyPr>
           <a:lstStyle/>
           <a:p>
-            <a:pPr indent="-355600" lvl="0" marL="457200" rtl="0" algn="l">
+            <a:pPr indent="-355600" lvl="0" marL="457200" rtl="0" algn="just">
               <a:lnSpc>
                 <a:spcPct val="115000"/>
               </a:lnSpc>
@@ -18518,14 +18742,14 @@
       </p:sp>
       <p:sp>
         <p:nvSpPr>
-          <p:cNvPr id="184" name="Google Shape;184;p27"/>
+          <p:cNvPr id="183" name="Google Shape;183;p27"/>
           <p:cNvSpPr txBox="1"/>
           <p:nvPr/>
         </p:nvSpPr>
         <p:spPr>
           <a:xfrm>
-            <a:off x="449517" y="2325379"/>
-            <a:ext cx="8078700" cy="1143000"/>
+            <a:off x="449525" y="2351150"/>
+            <a:ext cx="8229600" cy="1143000"/>
           </a:xfrm>
           <a:prstGeom prst="rect">
             <a:avLst/>
@@ -18541,7 +18765,7 @@
           </a:bodyPr>
           <a:lstStyle/>
           <a:p>
-            <a:pPr indent="-355600" lvl="0" marL="457200" rtl="0" algn="l">
+            <a:pPr indent="-355600" lvl="0" marL="457200" rtl="0" algn="just">
               <a:lnSpc>
                 <a:spcPct val="115000"/>
               </a:lnSpc>
@@ -18606,14 +18830,14 @@
       </p:sp>
       <p:sp>
         <p:nvSpPr>
-          <p:cNvPr id="185" name="Google Shape;185;p27"/>
+          <p:cNvPr id="184" name="Google Shape;184;p27"/>
           <p:cNvSpPr txBox="1"/>
           <p:nvPr/>
         </p:nvSpPr>
         <p:spPr>
           <a:xfrm>
-            <a:off x="435104" y="3434769"/>
-            <a:ext cx="7708200" cy="1143000"/>
+            <a:off x="435100" y="3460550"/>
+            <a:ext cx="8229600" cy="1143000"/>
           </a:xfrm>
           <a:prstGeom prst="rect">
             <a:avLst/>
@@ -18629,7 +18853,7 @@
           </a:bodyPr>
           <a:lstStyle/>
           <a:p>
-            <a:pPr indent="-355600" lvl="0" marL="457200" rtl="0" algn="l">
+            <a:pPr indent="-355600" lvl="0" marL="457200" rtl="0" algn="just">
               <a:lnSpc>
                 <a:spcPct val="115000"/>
               </a:lnSpc>
@@ -18671,14 +18895,14 @@
       </p:sp>
       <p:sp>
         <p:nvSpPr>
-          <p:cNvPr id="186" name="Google Shape;186;p27"/>
+          <p:cNvPr id="185" name="Google Shape;185;p27"/>
           <p:cNvSpPr txBox="1"/>
           <p:nvPr/>
         </p:nvSpPr>
         <p:spPr>
           <a:xfrm>
-            <a:off x="435109" y="4918742"/>
-            <a:ext cx="7708200" cy="768300"/>
+            <a:off x="435100" y="4944525"/>
+            <a:ext cx="8229600" cy="768300"/>
           </a:xfrm>
           <a:prstGeom prst="rect">
             <a:avLst/>
@@ -18694,7 +18918,7 @@
           </a:bodyPr>
           <a:lstStyle/>
           <a:p>
-            <a:pPr indent="-355600" lvl="0" marL="457200" rtl="0" algn="l">
+            <a:pPr indent="-355600" lvl="0" marL="457200" rtl="0" algn="just">
               <a:lnSpc>
                 <a:spcPct val="115000"/>
               </a:lnSpc>
@@ -18720,7 +18944,7 @@
                 <a:cs typeface="Calibri"/>
                 <a:sym typeface="Calibri"/>
               </a:rPr>
-              <a:t>The final output is a risk score with its confidence and explanation, converted into a plain-language report by an LLM.</a:t>
+              <a:t>The final output is a risk score with its confidence and explanation.</a:t>
             </a:r>
             <a:endParaRPr sz="3200">
               <a:solidFill>
@@ -18747,7 +18971,7 @@
   <p:cSld>
     <p:spTree>
       <p:nvGrpSpPr>
-        <p:cNvPr id="190" name="Shape 190"/>
+        <p:cNvPr id="189" name="Shape 189"/>
         <p:cNvGrpSpPr/>
         <p:nvPr/>
       </p:nvGrpSpPr>
@@ -18761,7 +18985,7 @@
       </p:grpSpPr>
       <p:sp>
         <p:nvSpPr>
-          <p:cNvPr id="191" name="Google Shape;191;p28"/>
+          <p:cNvPr id="190" name="Google Shape;190;p28"/>
           <p:cNvSpPr txBox="1"/>
           <p:nvPr>
             <p:ph type="title"/>
@@ -18818,7 +19042,7 @@
       </p:sp>
       <p:sp>
         <p:nvSpPr>
-          <p:cNvPr id="192" name="Google Shape;192;p28"/>
+          <p:cNvPr id="191" name="Google Shape;191;p28"/>
           <p:cNvSpPr/>
           <p:nvPr/>
         </p:nvSpPr>
@@ -18869,7 +19093,7 @@
       </p:sp>
       <p:sp>
         <p:nvSpPr>
-          <p:cNvPr id="193" name="Google Shape;193;p28"/>
+          <p:cNvPr id="192" name="Google Shape;192;p28"/>
           <p:cNvSpPr/>
           <p:nvPr/>
         </p:nvSpPr>
@@ -18932,7 +19156,7 @@
       </p:sp>
       <p:cxnSp>
         <p:nvCxnSpPr>
-          <p:cNvPr id="194" name="Google Shape;194;p28"/>
+          <p:cNvPr id="193" name="Google Shape;193;p28"/>
           <p:cNvCxnSpPr/>
           <p:nvPr/>
         </p:nvCxnSpPr>
@@ -18958,7 +19182,7 @@
       </p:cxnSp>
       <p:sp>
         <p:nvSpPr>
-          <p:cNvPr id="195" name="Google Shape;195;p28"/>
+          <p:cNvPr id="194" name="Google Shape;194;p28"/>
           <p:cNvSpPr/>
           <p:nvPr/>
         </p:nvSpPr>
@@ -19009,7 +19233,7 @@
       </p:sp>
       <p:sp>
         <p:nvSpPr>
-          <p:cNvPr id="196" name="Google Shape;196;p28"/>
+          <p:cNvPr id="195" name="Google Shape;195;p28"/>
           <p:cNvSpPr/>
           <p:nvPr/>
         </p:nvSpPr>
@@ -19072,7 +19296,7 @@
       </p:sp>
       <p:cxnSp>
         <p:nvCxnSpPr>
-          <p:cNvPr id="197" name="Google Shape;197;p28"/>
+          <p:cNvPr id="196" name="Google Shape;196;p28"/>
           <p:cNvCxnSpPr/>
           <p:nvPr/>
         </p:nvCxnSpPr>
@@ -19098,7 +19322,7 @@
       </p:cxnSp>
       <p:sp>
         <p:nvSpPr>
-          <p:cNvPr id="198" name="Google Shape;198;p28"/>
+          <p:cNvPr id="197" name="Google Shape;197;p28"/>
           <p:cNvSpPr/>
           <p:nvPr/>
         </p:nvSpPr>
@@ -19149,7 +19373,7 @@
       </p:sp>
       <p:sp>
         <p:nvSpPr>
-          <p:cNvPr id="199" name="Google Shape;199;p28"/>
+          <p:cNvPr id="198" name="Google Shape;198;p28"/>
           <p:cNvSpPr/>
           <p:nvPr/>
         </p:nvSpPr>
@@ -19212,7 +19436,7 @@
       </p:sp>
       <p:cxnSp>
         <p:nvCxnSpPr>
-          <p:cNvPr id="200" name="Google Shape;200;p28"/>
+          <p:cNvPr id="199" name="Google Shape;199;p28"/>
           <p:cNvCxnSpPr/>
           <p:nvPr/>
         </p:nvCxnSpPr>
@@ -19238,7 +19462,7 @@
       </p:cxnSp>
       <p:sp>
         <p:nvSpPr>
-          <p:cNvPr id="201" name="Google Shape;201;p28"/>
+          <p:cNvPr id="200" name="Google Shape;200;p28"/>
           <p:cNvSpPr/>
           <p:nvPr/>
         </p:nvSpPr>
@@ -19289,7 +19513,7 @@
       </p:sp>
       <p:sp>
         <p:nvSpPr>
-          <p:cNvPr id="202" name="Google Shape;202;p28"/>
+          <p:cNvPr id="201" name="Google Shape;201;p28"/>
           <p:cNvSpPr/>
           <p:nvPr/>
         </p:nvSpPr>
@@ -19352,7 +19576,7 @@
       </p:sp>
       <p:cxnSp>
         <p:nvCxnSpPr>
-          <p:cNvPr id="203" name="Google Shape;203;p28"/>
+          <p:cNvPr id="202" name="Google Shape;202;p28"/>
           <p:cNvCxnSpPr/>
           <p:nvPr/>
         </p:nvCxnSpPr>
@@ -19378,7 +19602,7 @@
       </p:cxnSp>
       <p:sp>
         <p:nvSpPr>
-          <p:cNvPr id="204" name="Google Shape;204;p28"/>
+          <p:cNvPr id="203" name="Google Shape;203;p28"/>
           <p:cNvSpPr/>
           <p:nvPr/>
         </p:nvSpPr>
@@ -19429,7 +19653,7 @@
       </p:sp>
       <p:sp>
         <p:nvSpPr>
-          <p:cNvPr id="205" name="Google Shape;205;p28"/>
+          <p:cNvPr id="204" name="Google Shape;204;p28"/>
           <p:cNvSpPr/>
           <p:nvPr/>
         </p:nvSpPr>
@@ -19492,7 +19716,7 @@
       </p:sp>
       <p:cxnSp>
         <p:nvCxnSpPr>
-          <p:cNvPr id="206" name="Google Shape;206;p28"/>
+          <p:cNvPr id="205" name="Google Shape;205;p28"/>
           <p:cNvCxnSpPr/>
           <p:nvPr/>
         </p:nvCxnSpPr>
@@ -19518,7 +19742,7 @@
       </p:cxnSp>
       <p:sp>
         <p:nvSpPr>
-          <p:cNvPr id="207" name="Google Shape;207;p28"/>
+          <p:cNvPr id="206" name="Google Shape;206;p28"/>
           <p:cNvSpPr/>
           <p:nvPr/>
         </p:nvSpPr>
@@ -19563,7 +19787,7 @@
       </p:sp>
       <p:sp>
         <p:nvSpPr>
-          <p:cNvPr id="208" name="Google Shape;208;p28"/>
+          <p:cNvPr id="207" name="Google Shape;207;p28"/>
           <p:cNvSpPr/>
           <p:nvPr/>
         </p:nvSpPr>
@@ -19626,7 +19850,7 @@
       </p:sp>
       <p:cxnSp>
         <p:nvCxnSpPr>
-          <p:cNvPr id="209" name="Google Shape;209;p28"/>
+          <p:cNvPr id="208" name="Google Shape;208;p28"/>
           <p:cNvCxnSpPr/>
           <p:nvPr/>
         </p:nvCxnSpPr>
@@ -19652,7 +19876,7 @@
       </p:cxnSp>
       <p:sp>
         <p:nvSpPr>
-          <p:cNvPr id="210" name="Google Shape;210;p28"/>
+          <p:cNvPr id="209" name="Google Shape;209;p28"/>
           <p:cNvSpPr/>
           <p:nvPr/>
         </p:nvSpPr>
@@ -19697,7 +19921,7 @@
       </p:sp>
       <p:sp>
         <p:nvSpPr>
-          <p:cNvPr id="211" name="Google Shape;211;p28"/>
+          <p:cNvPr id="210" name="Google Shape;210;p28"/>
           <p:cNvSpPr/>
           <p:nvPr/>
         </p:nvSpPr>
@@ -19760,7 +19984,7 @@
       </p:sp>
       <p:cxnSp>
         <p:nvCxnSpPr>
-          <p:cNvPr id="212" name="Google Shape;212;p28"/>
+          <p:cNvPr id="211" name="Google Shape;211;p28"/>
           <p:cNvCxnSpPr/>
           <p:nvPr/>
         </p:nvCxnSpPr>
@@ -19786,7 +20010,7 @@
       </p:cxnSp>
       <p:sp>
         <p:nvSpPr>
-          <p:cNvPr id="213" name="Google Shape;213;p28"/>
+          <p:cNvPr id="212" name="Google Shape;212;p28"/>
           <p:cNvSpPr/>
           <p:nvPr/>
         </p:nvSpPr>
@@ -19831,7 +20055,7 @@
       </p:sp>
       <p:sp>
         <p:nvSpPr>
-          <p:cNvPr id="214" name="Google Shape;214;p28"/>
+          <p:cNvPr id="213" name="Google Shape;213;p28"/>
           <p:cNvSpPr/>
           <p:nvPr/>
         </p:nvSpPr>
@@ -19894,7 +20118,7 @@
       </p:sp>
       <p:cxnSp>
         <p:nvCxnSpPr>
-          <p:cNvPr id="215" name="Google Shape;215;p28"/>
+          <p:cNvPr id="214" name="Google Shape;214;p28"/>
           <p:cNvCxnSpPr/>
           <p:nvPr/>
         </p:nvCxnSpPr>
@@ -19920,7 +20144,7 @@
       </p:cxnSp>
       <p:sp>
         <p:nvSpPr>
-          <p:cNvPr id="216" name="Google Shape;216;p28"/>
+          <p:cNvPr id="215" name="Google Shape;215;p28"/>
           <p:cNvSpPr/>
           <p:nvPr/>
         </p:nvSpPr>
@@ -19965,7 +20189,7 @@
       </p:sp>
       <p:sp>
         <p:nvSpPr>
-          <p:cNvPr id="217" name="Google Shape;217;p28"/>
+          <p:cNvPr id="216" name="Google Shape;216;p28"/>
           <p:cNvSpPr/>
           <p:nvPr/>
         </p:nvSpPr>
@@ -20028,7 +20252,7 @@
       </p:sp>
       <p:cxnSp>
         <p:nvCxnSpPr>
-          <p:cNvPr id="218" name="Google Shape;218;p28"/>
+          <p:cNvPr id="217" name="Google Shape;217;p28"/>
           <p:cNvCxnSpPr/>
           <p:nvPr/>
         </p:nvCxnSpPr>
@@ -20054,7 +20278,7 @@
       </p:cxnSp>
       <p:sp>
         <p:nvSpPr>
-          <p:cNvPr id="219" name="Google Shape;219;p28"/>
+          <p:cNvPr id="218" name="Google Shape;218;p28"/>
           <p:cNvSpPr/>
           <p:nvPr/>
         </p:nvSpPr>
@@ -20099,7 +20323,7 @@
       </p:sp>
       <p:sp>
         <p:nvSpPr>
-          <p:cNvPr id="220" name="Google Shape;220;p28"/>
+          <p:cNvPr id="219" name="Google Shape;219;p28"/>
           <p:cNvSpPr/>
           <p:nvPr/>
         </p:nvSpPr>
@@ -20162,7 +20386,7 @@
       </p:sp>
       <p:cxnSp>
         <p:nvCxnSpPr>
-          <p:cNvPr id="221" name="Google Shape;221;p28"/>
+          <p:cNvPr id="220" name="Google Shape;220;p28"/>
           <p:cNvCxnSpPr/>
           <p:nvPr/>
         </p:nvCxnSpPr>
@@ -20188,7 +20412,7 @@
       </p:cxnSp>
       <p:cxnSp>
         <p:nvCxnSpPr>
-          <p:cNvPr id="222" name="Google Shape;222;p28"/>
+          <p:cNvPr id="221" name="Google Shape;221;p28"/>
           <p:cNvCxnSpPr/>
           <p:nvPr/>
         </p:nvCxnSpPr>
@@ -20214,7 +20438,7 @@
       </p:cxnSp>
       <p:cxnSp>
         <p:nvCxnSpPr>
-          <p:cNvPr id="223" name="Google Shape;223;p28"/>
+          <p:cNvPr id="222" name="Google Shape;222;p28"/>
           <p:cNvCxnSpPr/>
           <p:nvPr/>
         </p:nvCxnSpPr>
@@ -20240,7 +20464,7 @@
       </p:cxnSp>
       <p:cxnSp>
         <p:nvCxnSpPr>
-          <p:cNvPr id="224" name="Google Shape;224;p28"/>
+          <p:cNvPr id="223" name="Google Shape;223;p28"/>
           <p:cNvCxnSpPr/>
           <p:nvPr/>
         </p:nvCxnSpPr>
@@ -20266,7 +20490,7 @@
       </p:cxnSp>
       <p:cxnSp>
         <p:nvCxnSpPr>
-          <p:cNvPr id="225" name="Google Shape;225;p28"/>
+          <p:cNvPr id="224" name="Google Shape;224;p28"/>
           <p:cNvCxnSpPr/>
           <p:nvPr/>
         </p:nvCxnSpPr>
@@ -20292,7 +20516,7 @@
       </p:cxnSp>
       <p:cxnSp>
         <p:nvCxnSpPr>
-          <p:cNvPr id="226" name="Google Shape;226;p28"/>
+          <p:cNvPr id="225" name="Google Shape;225;p28"/>
           <p:cNvCxnSpPr/>
           <p:nvPr/>
         </p:nvCxnSpPr>
@@ -20318,7 +20542,7 @@
       </p:cxnSp>
       <p:sp>
         <p:nvSpPr>
-          <p:cNvPr id="227" name="Google Shape;227;p28"/>
+          <p:cNvPr id="226" name="Google Shape;226;p28"/>
           <p:cNvSpPr/>
           <p:nvPr/>
         </p:nvSpPr>
@@ -20370,7 +20594,7 @@
       </p:sp>
       <p:sp>
         <p:nvSpPr>
-          <p:cNvPr id="228" name="Google Shape;228;p28"/>
+          <p:cNvPr id="227" name="Google Shape;227;p28"/>
           <p:cNvSpPr/>
           <p:nvPr/>
         </p:nvSpPr>
@@ -20556,7 +20780,7 @@
       </p:sp>
       <p:cxnSp>
         <p:nvCxnSpPr>
-          <p:cNvPr id="229" name="Google Shape;229;p28"/>
+          <p:cNvPr id="228" name="Google Shape;228;p28"/>
           <p:cNvCxnSpPr/>
           <p:nvPr/>
         </p:nvCxnSpPr>
@@ -20582,7 +20806,7 @@
       </p:cxnSp>
       <p:sp>
         <p:nvSpPr>
-          <p:cNvPr id="230" name="Google Shape;230;p28"/>
+          <p:cNvPr id="229" name="Google Shape;229;p28"/>
           <p:cNvSpPr/>
           <p:nvPr/>
         </p:nvSpPr>
@@ -20633,7 +20857,7 @@
       </p:sp>
       <p:sp>
         <p:nvSpPr>
-          <p:cNvPr id="231" name="Google Shape;231;p28"/>
+          <p:cNvPr id="230" name="Google Shape;230;p28"/>
           <p:cNvSpPr/>
           <p:nvPr/>
         </p:nvSpPr>
@@ -20699,7 +20923,7 @@
       </p:sp>
       <p:sp>
         <p:nvSpPr>
-          <p:cNvPr id="232" name="Google Shape;232;p28"/>
+          <p:cNvPr id="231" name="Google Shape;231;p28"/>
           <p:cNvSpPr/>
           <p:nvPr/>
         </p:nvSpPr>
@@ -20750,7 +20974,7 @@
       </p:sp>
       <p:sp>
         <p:nvSpPr>
-          <p:cNvPr id="233" name="Google Shape;233;p28"/>
+          <p:cNvPr id="232" name="Google Shape;232;p28"/>
           <p:cNvSpPr/>
           <p:nvPr/>
         </p:nvSpPr>
@@ -20856,7 +21080,7 @@
       </p:sp>
       <p:sp>
         <p:nvSpPr>
-          <p:cNvPr id="234" name="Google Shape;234;p28"/>
+          <p:cNvPr id="233" name="Google Shape;233;p28"/>
           <p:cNvSpPr/>
           <p:nvPr/>
         </p:nvSpPr>
@@ -20907,7 +21131,7 @@
       </p:sp>
       <p:sp>
         <p:nvSpPr>
-          <p:cNvPr id="235" name="Google Shape;235;p28"/>
+          <p:cNvPr id="234" name="Google Shape;234;p28"/>
           <p:cNvSpPr/>
           <p:nvPr/>
         </p:nvSpPr>
@@ -20973,7 +21197,7 @@
       </p:sp>
       <p:sp>
         <p:nvSpPr>
-          <p:cNvPr id="236" name="Google Shape;236;p28"/>
+          <p:cNvPr id="235" name="Google Shape;235;p28"/>
           <p:cNvSpPr/>
           <p:nvPr/>
         </p:nvSpPr>
@@ -21024,7 +21248,7 @@
       </p:sp>
       <p:sp>
         <p:nvSpPr>
-          <p:cNvPr id="237" name="Google Shape;237;p28"/>
+          <p:cNvPr id="236" name="Google Shape;236;p28"/>
           <p:cNvSpPr/>
           <p:nvPr/>
         </p:nvSpPr>
@@ -21065,7 +21289,7 @@
               <a:buNone/>
             </a:pPr>
             <a:r>
-              <a:rPr b="1" i="0" lang="en-US" sz="1600" u="none" cap="none" strike="noStrike">
+              <a:rPr b="1" lang="en-US" sz="1600">
                 <a:solidFill>
                   <a:srgbClr val="0B3D59"/>
                 </a:solidFill>
@@ -21074,47 +21298,7 @@
                 <a:cs typeface="Calibri"/>
                 <a:sym typeface="Calibri"/>
               </a:rPr>
-              <a:t>LLM patient</a:t>
-            </a:r>
-            <a:endParaRPr b="0" i="0" sz="1600" u="none" cap="none" strike="noStrike">
-              <a:solidFill>
-                <a:srgbClr val="000000"/>
-              </a:solidFill>
-              <a:latin typeface="Calibri"/>
-              <a:ea typeface="Calibri"/>
-              <a:cs typeface="Calibri"/>
-              <a:sym typeface="Calibri"/>
-            </a:endParaRPr>
-          </a:p>
-          <a:p>
-            <a:pPr indent="0" lvl="0" marL="0" marR="0" rtl="0" algn="ctr">
-              <a:lnSpc>
-                <a:spcPct val="100000"/>
-              </a:lnSpc>
-              <a:spcBef>
-                <a:spcPts val="0"/>
-              </a:spcBef>
-              <a:spcAft>
-                <a:spcPts val="0"/>
-              </a:spcAft>
-              <a:buClr>
-                <a:srgbClr val="0B3D59"/>
-              </a:buClr>
-              <a:buSzPts val="1000"/>
-              <a:buFont typeface="Calibri"/>
-              <a:buNone/>
-            </a:pPr>
-            <a:r>
-              <a:rPr b="1" i="0" lang="en-US" sz="1600" u="none" cap="none" strike="noStrike">
-                <a:solidFill>
-                  <a:srgbClr val="0B3D59"/>
-                </a:solidFill>
-                <a:latin typeface="Calibri"/>
-                <a:ea typeface="Calibri"/>
-                <a:cs typeface="Calibri"/>
-                <a:sym typeface="Calibri"/>
-              </a:rPr>
-              <a:t>report</a:t>
+              <a:t>Modality Contribution Breakdown</a:t>
             </a:r>
             <a:endParaRPr b="0" i="0" sz="1600" u="none" cap="none" strike="noStrike">
               <a:solidFill>
@@ -21141,7 +21325,7 @@
   <p:cSld>
     <p:spTree>
       <p:nvGrpSpPr>
-        <p:cNvPr id="241" name="Shape 241"/>
+        <p:cNvPr id="240" name="Shape 240"/>
         <p:cNvGrpSpPr/>
         <p:nvPr/>
       </p:nvGrpSpPr>
@@ -21155,7 +21339,7 @@
       </p:grpSpPr>
       <p:sp>
         <p:nvSpPr>
-          <p:cNvPr id="242" name="Google Shape;242;p29"/>
+          <p:cNvPr id="241" name="Google Shape;241;p29"/>
           <p:cNvSpPr txBox="1"/>
           <p:nvPr>
             <p:ph type="title"/>
@@ -21211,7 +21395,7 @@
       </p:sp>
       <p:sp>
         <p:nvSpPr>
-          <p:cNvPr id="243" name="Google Shape;243;p29"/>
+          <p:cNvPr id="242" name="Google Shape;242;p29"/>
           <p:cNvSpPr txBox="1"/>
           <p:nvPr>
             <p:ph idx="1" type="body"/>
@@ -21273,7 +21457,7 @@
   <p:cSld>
     <p:spTree>
       <p:nvGrpSpPr>
-        <p:cNvPr id="247" name="Shape 247"/>
+        <p:cNvPr id="246" name="Shape 246"/>
         <p:cNvGrpSpPr/>
         <p:nvPr/>
       </p:nvGrpSpPr>
@@ -21287,7 +21471,7 @@
       </p:grpSpPr>
       <p:sp>
         <p:nvSpPr>
-          <p:cNvPr id="248" name="Google Shape;248;p30"/>
+          <p:cNvPr id="247" name="Google Shape;247;p30"/>
           <p:cNvSpPr txBox="1"/>
           <p:nvPr>
             <p:ph type="title"/>
@@ -21312,7 +21496,7 @@
           </a:bodyPr>
           <a:lstStyle/>
           <a:p>
-            <a:pPr indent="0" lvl="0" marL="0" rtl="0" algn="ctr">
+            <a:pPr indent="0" lvl="0" marL="0" rtl="0" algn="just">
               <a:spcBef>
                 <a:spcPts val="0"/>
               </a:spcBef>
@@ -21336,7 +21520,7 @@
       </p:sp>
       <p:sp>
         <p:nvSpPr>
-          <p:cNvPr id="249" name="Google Shape;249;p30"/>
+          <p:cNvPr id="248" name="Google Shape;248;p30"/>
           <p:cNvSpPr txBox="1"/>
           <p:nvPr>
             <p:ph idx="1" type="body"/>
@@ -21361,7 +21545,7 @@
           </a:bodyPr>
           <a:lstStyle/>
           <a:p>
-            <a:pPr indent="-355600" lvl="0" marL="457200" rtl="0" algn="l">
+            <a:pPr indent="-355600" lvl="0" marL="457200" rtl="0" algn="just">
               <a:lnSpc>
                 <a:spcPct val="150000"/>
               </a:lnSpc>
@@ -21376,12 +21560,12 @@
             </a:pPr>
             <a:r>
               <a:rPr lang="en-US" sz="2000"/>
-              <a:t>Image capture and preprocessing for multiple body surfaces: oral cavity, fingernails, conjunctiva, tongue, palm</a:t>
+              <a:t>Cross-platform mobile application for capturing and submitting body-surface images, and viewing results</a:t>
             </a:r>
             <a:endParaRPr sz="2000"/>
           </a:p>
           <a:p>
-            <a:pPr indent="-355600" lvl="0" marL="457200" rtl="0" algn="l">
+            <a:pPr indent="-355600" lvl="0" marL="457200" rtl="0" algn="just">
               <a:lnSpc>
                 <a:spcPct val="150000"/>
               </a:lnSpc>
@@ -21396,12 +21580,12 @@
             </a:pPr>
             <a:r>
               <a:rPr lang="en-US" sz="2000"/>
-              <a:t>Five specialist ViT-B/16 encoders, one per surface</a:t>
+              <a:t>Screening across five body surfaces: oral cavity, fingernails, conjunctiva, tongue, palm, with a modular design allowing a surface to be substituted if needed</a:t>
             </a:r>
             <a:endParaRPr sz="2000"/>
           </a:p>
           <a:p>
-            <a:pPr indent="-355600" lvl="0" marL="457200" rtl="0" algn="l">
+            <a:pPr indent="-355600" lvl="0" marL="457200" rtl="0" algn="just">
               <a:lnSpc>
                 <a:spcPct val="150000"/>
               </a:lnSpc>
@@ -21421,7 +21605,7 @@
             <a:endParaRPr sz="2000"/>
           </a:p>
           <a:p>
-            <a:pPr indent="-355600" lvl="0" marL="457200" rtl="0" algn="l">
+            <a:pPr indent="-355600" lvl="0" marL="457200" rtl="0" algn="just">
               <a:lnSpc>
                 <a:spcPct val="150000"/>
               </a:lnSpc>
@@ -21441,7 +21625,7 @@
             <a:endParaRPr sz="2000"/>
           </a:p>
           <a:p>
-            <a:pPr indent="-355600" lvl="0" marL="457200" rtl="0" algn="l">
+            <a:pPr indent="-355600" lvl="0" marL="457200" rtl="0" algn="just">
               <a:lnSpc>
                 <a:spcPct val="150000"/>
               </a:lnSpc>
@@ -21456,12 +21640,12 @@
             </a:pPr>
             <a:r>
               <a:rPr lang="en-US" sz="2000"/>
-              <a:t>Attention-based explainability </a:t>
+              <a:t>Attention-based Visual explanation showing which regions influenced the result</a:t>
             </a:r>
             <a:endParaRPr sz="2000"/>
           </a:p>
           <a:p>
-            <a:pPr indent="-355600" lvl="0" marL="457200" rtl="0" algn="l">
+            <a:pPr indent="-355600" lvl="0" marL="457200" rtl="0" algn="just">
               <a:lnSpc>
                 <a:spcPct val="150000"/>
               </a:lnSpc>
@@ -21477,46 +21661,6 @@
             <a:r>
               <a:rPr lang="en-US" sz="2000"/>
               <a:t>Missing-modality robustness handling</a:t>
-            </a:r>
-            <a:endParaRPr sz="2000"/>
-          </a:p>
-          <a:p>
-            <a:pPr indent="-355600" lvl="0" marL="457200" rtl="0" algn="l">
-              <a:lnSpc>
-                <a:spcPct val="150000"/>
-              </a:lnSpc>
-              <a:spcBef>
-                <a:spcPts val="0"/>
-              </a:spcBef>
-              <a:spcAft>
-                <a:spcPts val="0"/>
-              </a:spcAft>
-              <a:buSzPts val="2000"/>
-              <a:buChar char="○"/>
-            </a:pPr>
-            <a:r>
-              <a:rPr lang="en-US" sz="2000"/>
-              <a:t>LLM-generated, patient-readable summary report</a:t>
-            </a:r>
-            <a:endParaRPr sz="2000"/>
-          </a:p>
-          <a:p>
-            <a:pPr indent="-355600" lvl="0" marL="457200" rtl="0" algn="l">
-              <a:lnSpc>
-                <a:spcPct val="150000"/>
-              </a:lnSpc>
-              <a:spcBef>
-                <a:spcPts val="0"/>
-              </a:spcBef>
-              <a:spcAft>
-                <a:spcPts val="0"/>
-              </a:spcAft>
-              <a:buSzPts val="2000"/>
-              <a:buChar char="○"/>
-            </a:pPr>
-            <a:r>
-              <a:rPr lang="en-US" sz="2000"/>
-              <a:t>Evaluation on public datasets: Piyarathne, Flügge et al. 2023 (Berlin OSCC), Rabinovici-Cohen et al. 2024</a:t>
             </a:r>
             <a:endParaRPr sz="2000"/>
           </a:p>
@@ -21535,7 +21679,7 @@
   <p:cSld>
     <p:spTree>
       <p:nvGrpSpPr>
-        <p:cNvPr id="253" name="Shape 253"/>
+        <p:cNvPr id="252" name="Shape 252"/>
         <p:cNvGrpSpPr/>
         <p:nvPr/>
       </p:nvGrpSpPr>
@@ -21549,7 +21693,7 @@
       </p:grpSpPr>
       <p:sp>
         <p:nvSpPr>
-          <p:cNvPr id="254" name="Google Shape;254;p31"/>
+          <p:cNvPr id="253" name="Google Shape;253;p31"/>
           <p:cNvSpPr txBox="1"/>
           <p:nvPr>
             <p:ph type="title"/>
@@ -21593,15 +21737,7 @@
                   <a:srgbClr val="0B3D59"/>
                 </a:solidFill>
               </a:rPr>
-              <a:t>Work Breakdown </a:t>
-            </a:r>
-            <a:r>
-              <a:rPr lang="en-US">
-                <a:solidFill>
-                  <a:srgbClr val="0B3D59"/>
-                </a:solidFill>
-              </a:rPr>
-              <a:t>&amp; Structure</a:t>
+              <a:t>Major Challenges</a:t>
             </a:r>
             <a:endParaRPr>
               <a:solidFill>
@@ -21613,7 +21749,7 @@
       </p:sp>
       <p:sp>
         <p:nvSpPr>
-          <p:cNvPr id="255" name="Google Shape;255;p31"/>
+          <p:cNvPr id="254" name="Google Shape;254;p31"/>
           <p:cNvSpPr txBox="1"/>
           <p:nvPr>
             <p:ph idx="1" type="body"/>
@@ -21903,7 +22039,7 @@
   <p:cSld>
     <p:spTree>
       <p:nvGrpSpPr>
-        <p:cNvPr id="259" name="Shape 259"/>
+        <p:cNvPr id="258" name="Shape 258"/>
         <p:cNvGrpSpPr/>
         <p:nvPr/>
       </p:nvGrpSpPr>
@@ -21917,7 +22053,7 @@
       </p:grpSpPr>
       <p:sp>
         <p:nvSpPr>
-          <p:cNvPr id="260" name="Google Shape;260;p32"/>
+          <p:cNvPr id="259" name="Google Shape;259;p32"/>
           <p:cNvSpPr txBox="1"/>
           <p:nvPr>
             <p:ph type="title"/>
@@ -21962,7 +22098,7 @@
                   <a:srgbClr val="0B3D59"/>
                 </a:solidFill>
               </a:rPr>
-              <a:t>Work Breakdown</a:t>
+              <a:t>Challenges</a:t>
             </a:r>
             <a:endParaRPr/>
           </a:p>
@@ -21970,7 +22106,7 @@
       </p:sp>
       <p:sp>
         <p:nvSpPr>
-          <p:cNvPr id="261" name="Google Shape;261;p32"/>
+          <p:cNvPr id="260" name="Google Shape;260;p32"/>
           <p:cNvSpPr txBox="1"/>
           <p:nvPr/>
         </p:nvSpPr>
@@ -21993,7 +22129,7 @@
           </a:bodyPr>
           <a:lstStyle/>
           <a:p>
-            <a:pPr indent="0" lvl="0" marL="0" rtl="0" algn="l">
+            <a:pPr indent="-355600" lvl="0" marL="457200" rtl="0" algn="just">
               <a:lnSpc>
                 <a:spcPct val="150000"/>
               </a:lnSpc>
@@ -22006,169 +22142,33 @@
               <a:buClr>
                 <a:schemeClr val="dk1"/>
               </a:buClr>
-              <a:buSzPts val="1100"/>
-              <a:buFont typeface="Arial"/>
-              <a:buNone/>
+              <a:buSzPts val="2000"/>
+              <a:buFont typeface="Calibri"/>
+              <a:buChar char="○"/>
             </a:pPr>
             <a:r>
               <a:rPr b="1" lang="en-US" sz="2000">
                 <a:solidFill>
                   <a:schemeClr val="dk1"/>
                 </a:solidFill>
+                <a:latin typeface="Calibri"/>
+                <a:ea typeface="Calibri"/>
+                <a:cs typeface="Calibri"/>
+                <a:sym typeface="Calibri"/>
               </a:rPr>
-              <a:t>Phase 1: Proposal &amp; Literature Foundation:</a:t>
+              <a:t>Class imbalance varies across modalities, </a:t>
             </a:r>
             <a:r>
               <a:rPr lang="en-US" sz="2000">
                 <a:solidFill>
                   <a:schemeClr val="dk1"/>
                 </a:solidFill>
+                <a:latin typeface="Calibri"/>
+                <a:ea typeface="Calibri"/>
+                <a:cs typeface="Calibri"/>
+                <a:sym typeface="Calibri"/>
               </a:rPr>
-              <a:t> Weeks 1-4</a:t>
-            </a:r>
-            <a:br>
-              <a:rPr lang="en-US" sz="2000">
-                <a:solidFill>
-                  <a:schemeClr val="dk1"/>
-                </a:solidFill>
-              </a:rPr>
-            </a:br>
-            <a:r>
-              <a:rPr lang="en-US" sz="2000">
-                <a:solidFill>
-                  <a:schemeClr val="dk1"/>
-                </a:solidFill>
-              </a:rPr>
-              <a:t>Finalize literature review, gap analysis, problem statement. Build and deliver proposal presentation.</a:t>
-            </a:r>
-            <a:endParaRPr i="1" sz="2000">
-              <a:solidFill>
-                <a:schemeClr val="dk1"/>
-              </a:solidFill>
-            </a:endParaRPr>
-          </a:p>
-          <a:p>
-            <a:pPr indent="0" lvl="0" marL="0" rtl="0" algn="l">
-              <a:lnSpc>
-                <a:spcPct val="150000"/>
-              </a:lnSpc>
-              <a:spcBef>
-                <a:spcPts val="1200"/>
-              </a:spcBef>
-              <a:spcAft>
-                <a:spcPts val="0"/>
-              </a:spcAft>
-              <a:buClr>
-                <a:schemeClr val="dk1"/>
-              </a:buClr>
-              <a:buSzPts val="1100"/>
-              <a:buFont typeface="Arial"/>
-              <a:buNone/>
-            </a:pPr>
-            <a:r>
-              <a:rPr b="1" lang="en-US" sz="2000">
-                <a:solidFill>
-                  <a:schemeClr val="dk1"/>
-                </a:solidFill>
-              </a:rPr>
-              <a:t>Phase 2: Data Pipeline &amp; Preprocessing:</a:t>
-            </a:r>
-            <a:r>
-              <a:rPr lang="en-US" sz="2000">
-                <a:solidFill>
-                  <a:schemeClr val="dk1"/>
-                </a:solidFill>
-              </a:rPr>
-              <a:t> Weeks 5-7</a:t>
-            </a:r>
-            <a:br>
-              <a:rPr lang="en-US" sz="2000">
-                <a:solidFill>
-                  <a:schemeClr val="dk1"/>
-                </a:solidFill>
-              </a:rPr>
-            </a:br>
-            <a:r>
-              <a:rPr lang="en-US" sz="2000">
-                <a:solidFill>
-                  <a:schemeClr val="dk1"/>
-                </a:solidFill>
-              </a:rPr>
-              <a:t>Collect and standardize all five modality datasets. Address class imbalance. Build train/validation/test splits.</a:t>
-            </a:r>
-            <a:endParaRPr sz="2000">
-              <a:solidFill>
-                <a:schemeClr val="dk1"/>
-              </a:solidFill>
-            </a:endParaRPr>
-          </a:p>
-          <a:p>
-            <a:pPr indent="0" lvl="0" marL="0" rtl="0" algn="l">
-              <a:lnSpc>
-                <a:spcPct val="150000"/>
-              </a:lnSpc>
-              <a:spcBef>
-                <a:spcPts val="1200"/>
-              </a:spcBef>
-              <a:spcAft>
-                <a:spcPts val="0"/>
-              </a:spcAft>
-              <a:buClr>
-                <a:schemeClr val="dk1"/>
-              </a:buClr>
-              <a:buSzPts val="1100"/>
-              <a:buFont typeface="Arial"/>
-              <a:buNone/>
-            </a:pPr>
-            <a:r>
-              <a:rPr b="1" lang="en-US" sz="2000">
-                <a:solidFill>
-                  <a:schemeClr val="dk1"/>
-                </a:solidFill>
-              </a:rPr>
-              <a:t>Phase 3: Encoder &amp; Fusion Development:</a:t>
-            </a:r>
-            <a:r>
-              <a:rPr lang="en-US" sz="2000">
-                <a:solidFill>
-                  <a:schemeClr val="dk1"/>
-                </a:solidFill>
-              </a:rPr>
-              <a:t> Weeks 8-10</a:t>
-            </a:r>
-            <a:br>
-              <a:rPr lang="en-US" sz="2000">
-                <a:solidFill>
-                  <a:schemeClr val="dk1"/>
-                </a:solidFill>
-              </a:rPr>
-            </a:br>
-            <a:r>
-              <a:rPr lang="en-US" sz="2000">
-                <a:solidFill>
-                  <a:schemeClr val="dk1"/>
-                </a:solidFill>
-              </a:rPr>
-              <a:t>Train five ViT-B/16 specialist encoders. Implement and tune the cross-modal attention fusion transformer.</a:t>
-            </a:r>
-            <a:endParaRPr i="1" sz="2000">
-              <a:solidFill>
-                <a:schemeClr val="dk1"/>
-              </a:solidFill>
-            </a:endParaRPr>
-          </a:p>
-          <a:p>
-            <a:pPr indent="0" lvl="0" marL="0" rtl="0" algn="l">
-              <a:spcBef>
-                <a:spcPts val="1200"/>
-              </a:spcBef>
-              <a:spcAft>
-                <a:spcPts val="0"/>
-              </a:spcAft>
-              <a:buNone/>
-            </a:pPr>
-            <a:r>
-              <a:t/>
+              <a:t>so each modality requires its own mitigation strategy.</a:t>
             </a:r>
             <a:endParaRPr sz="2000">
               <a:solidFill>
@@ -22178,6 +22178,181 @@
               <a:ea typeface="Calibri"/>
               <a:cs typeface="Calibri"/>
               <a:sym typeface="Calibri"/>
+            </a:endParaRPr>
+          </a:p>
+          <a:p>
+            <a:pPr indent="-355600" lvl="0" marL="457200" rtl="0" algn="just">
+              <a:lnSpc>
+                <a:spcPct val="150000"/>
+              </a:lnSpc>
+              <a:spcBef>
+                <a:spcPts val="0"/>
+              </a:spcBef>
+              <a:spcAft>
+                <a:spcPts val="0"/>
+              </a:spcAft>
+              <a:buClr>
+                <a:schemeClr val="dk1"/>
+              </a:buClr>
+              <a:buSzPts val="2000"/>
+              <a:buFont typeface="Calibri"/>
+              <a:buChar char="○"/>
+            </a:pPr>
+            <a:r>
+              <a:rPr b="1" lang="en-US" sz="2000">
+                <a:solidFill>
+                  <a:schemeClr val="dk1"/>
+                </a:solidFill>
+                <a:latin typeface="Calibri"/>
+                <a:ea typeface="Calibri"/>
+                <a:cs typeface="Calibri"/>
+                <a:sym typeface="Calibri"/>
+              </a:rPr>
+              <a:t>Fusing five independent encoders into one coherent model.</a:t>
+            </a:r>
+            <a:r>
+              <a:rPr lang="en-US" sz="2000">
+                <a:solidFill>
+                  <a:schemeClr val="dk1"/>
+                </a:solidFill>
+                <a:latin typeface="Calibri"/>
+                <a:ea typeface="Calibri"/>
+                <a:cs typeface="Calibri"/>
+                <a:sym typeface="Calibri"/>
+              </a:rPr>
+              <a:t> Cross-modal attention fusion is the core contribution and the highest-risk component. No prior system fuses this many surfaces this way.</a:t>
+            </a:r>
+            <a:endParaRPr sz="2000">
+              <a:solidFill>
+                <a:schemeClr val="dk1"/>
+              </a:solidFill>
+              <a:latin typeface="Calibri"/>
+              <a:ea typeface="Calibri"/>
+              <a:cs typeface="Calibri"/>
+              <a:sym typeface="Calibri"/>
+            </a:endParaRPr>
+          </a:p>
+          <a:p>
+            <a:pPr indent="-355600" lvl="0" marL="457200" rtl="0" algn="just">
+              <a:lnSpc>
+                <a:spcPct val="150000"/>
+              </a:lnSpc>
+              <a:spcBef>
+                <a:spcPts val="0"/>
+              </a:spcBef>
+              <a:spcAft>
+                <a:spcPts val="0"/>
+              </a:spcAft>
+              <a:buClr>
+                <a:schemeClr val="dk1"/>
+              </a:buClr>
+              <a:buSzPts val="2000"/>
+              <a:buFont typeface="Calibri"/>
+              <a:buChar char="○"/>
+            </a:pPr>
+            <a:r>
+              <a:rPr b="1" lang="en-US" sz="2000">
+                <a:solidFill>
+                  <a:schemeClr val="dk1"/>
+                </a:solidFill>
+                <a:latin typeface="Calibri"/>
+                <a:ea typeface="Calibri"/>
+                <a:cs typeface="Calibri"/>
+                <a:sym typeface="Calibri"/>
+              </a:rPr>
+              <a:t>Explainability on Vision Transformers.</a:t>
+            </a:r>
+            <a:r>
+              <a:rPr lang="en-US" sz="2000">
+                <a:solidFill>
+                  <a:schemeClr val="dk1"/>
+                </a:solidFill>
+                <a:latin typeface="Calibri"/>
+                <a:ea typeface="Calibri"/>
+                <a:cs typeface="Calibri"/>
+                <a:sym typeface="Calibri"/>
+              </a:rPr>
+              <a:t> Standard Grad-CAM doesn't apply to ViT architectures. They require an attention-based method adapted specifically for transformers.</a:t>
+            </a:r>
+            <a:endParaRPr sz="2000">
+              <a:solidFill>
+                <a:schemeClr val="dk1"/>
+              </a:solidFill>
+              <a:latin typeface="Calibri"/>
+              <a:ea typeface="Calibri"/>
+              <a:cs typeface="Calibri"/>
+              <a:sym typeface="Calibri"/>
+            </a:endParaRPr>
+          </a:p>
+          <a:p>
+            <a:pPr indent="-355600" lvl="0" marL="457200" rtl="0" algn="just">
+              <a:lnSpc>
+                <a:spcPct val="150000"/>
+              </a:lnSpc>
+              <a:spcBef>
+                <a:spcPts val="0"/>
+              </a:spcBef>
+              <a:spcAft>
+                <a:spcPts val="0"/>
+              </a:spcAft>
+              <a:buClr>
+                <a:schemeClr val="dk1"/>
+              </a:buClr>
+              <a:buSzPts val="2000"/>
+              <a:buFont typeface="Calibri"/>
+              <a:buChar char="○"/>
+            </a:pPr>
+            <a:r>
+              <a:rPr b="1" lang="en-US" sz="2000">
+                <a:solidFill>
+                  <a:schemeClr val="dk1"/>
+                </a:solidFill>
+                <a:latin typeface="Calibri"/>
+                <a:ea typeface="Calibri"/>
+                <a:cs typeface="Calibri"/>
+                <a:sym typeface="Calibri"/>
+              </a:rPr>
+              <a:t>Domain Shift: </a:t>
+            </a:r>
+            <a:r>
+              <a:rPr lang="en-US" sz="2000">
+                <a:solidFill>
+                  <a:schemeClr val="dk1"/>
+                </a:solidFill>
+                <a:latin typeface="Calibri"/>
+                <a:ea typeface="Calibri"/>
+                <a:cs typeface="Calibri"/>
+                <a:sym typeface="Calibri"/>
+              </a:rPr>
+              <a:t>Domain gap between training data and real-world captures.</a:t>
+            </a:r>
+            <a:endParaRPr sz="2000">
+              <a:solidFill>
+                <a:schemeClr val="dk1"/>
+              </a:solidFill>
+              <a:latin typeface="Calibri"/>
+              <a:ea typeface="Calibri"/>
+              <a:cs typeface="Calibri"/>
+              <a:sym typeface="Calibri"/>
+            </a:endParaRPr>
+          </a:p>
+          <a:p>
+            <a:pPr indent="0" lvl="0" marL="0" rtl="0" algn="l">
+              <a:spcBef>
+                <a:spcPts val="0"/>
+              </a:spcBef>
+              <a:spcAft>
+                <a:spcPts val="0"/>
+              </a:spcAft>
+              <a:buNone/>
+            </a:pPr>
+            <a:r>
+              <a:t/>
+            </a:r>
+            <a:endParaRPr sz="2200">
+              <a:solidFill>
+                <a:schemeClr val="dk1"/>
+              </a:solidFill>
             </a:endParaRPr>
           </a:p>
         </p:txBody>
@@ -22195,7 +22370,7 @@
   <p:cSld>
     <p:spTree>
       <p:nvGrpSpPr>
-        <p:cNvPr id="265" name="Shape 265"/>
+        <p:cNvPr id="264" name="Shape 264"/>
         <p:cNvGrpSpPr/>
         <p:nvPr/>
       </p:nvGrpSpPr>
@@ -22209,7 +22384,139 @@
       </p:grpSpPr>
       <p:sp>
         <p:nvSpPr>
+          <p:cNvPr id="265" name="Google Shape;265;p33"/>
+          <p:cNvSpPr txBox="1"/>
+          <p:nvPr>
+            <p:ph type="title"/>
+          </p:nvPr>
+        </p:nvSpPr>
+        <p:spPr>
+          <a:xfrm>
+            <a:off x="722313" y="4406900"/>
+            <a:ext cx="7772400" cy="1362000"/>
+          </a:xfrm>
+          <a:prstGeom prst="rect">
+            <a:avLst/>
+          </a:prstGeom>
+          <a:noFill/>
+          <a:ln>
+            <a:noFill/>
+          </a:ln>
+        </p:spPr>
+        <p:txBody>
+          <a:bodyPr anchorCtr="0" anchor="t" bIns="45700" lIns="91425" spcFirstLastPara="1" rIns="91425" wrap="square" tIns="45700">
+            <a:normAutofit/>
+          </a:bodyPr>
+          <a:lstStyle/>
+          <a:p>
+            <a:pPr indent="0" lvl="0" marL="0" rtl="0" algn="l">
+              <a:lnSpc>
+                <a:spcPct val="100000"/>
+              </a:lnSpc>
+              <a:spcBef>
+                <a:spcPts val="0"/>
+              </a:spcBef>
+              <a:spcAft>
+                <a:spcPts val="0"/>
+              </a:spcAft>
+              <a:buSzPts val="1400"/>
+              <a:buNone/>
+            </a:pPr>
+            <a:r>
+              <a:rPr lang="en-US">
+                <a:solidFill>
+                  <a:srgbClr val="0B3D59"/>
+                </a:solidFill>
+              </a:rPr>
+              <a:t>Work Breakdown &amp; Structure</a:t>
+            </a:r>
+            <a:endParaRPr>
+              <a:solidFill>
+                <a:srgbClr val="0B3D59"/>
+              </a:solidFill>
+            </a:endParaRPr>
+          </a:p>
+        </p:txBody>
+      </p:sp>
+      <p:sp>
+        <p:nvSpPr>
           <p:cNvPr id="266" name="Google Shape;266;p33"/>
+          <p:cNvSpPr txBox="1"/>
+          <p:nvPr>
+            <p:ph idx="1" type="body"/>
+          </p:nvPr>
+        </p:nvSpPr>
+        <p:spPr>
+          <a:xfrm>
+            <a:off x="722313" y="2906713"/>
+            <a:ext cx="7772400" cy="1500300"/>
+          </a:xfrm>
+          <a:prstGeom prst="rect">
+            <a:avLst/>
+          </a:prstGeom>
+          <a:noFill/>
+          <a:ln>
+            <a:noFill/>
+          </a:ln>
+        </p:spPr>
+        <p:txBody>
+          <a:bodyPr anchorCtr="0" anchor="b" bIns="45700" lIns="91425" spcFirstLastPara="1" rIns="91425" wrap="square" tIns="45700">
+            <a:normAutofit/>
+          </a:bodyPr>
+          <a:lstStyle/>
+          <a:p>
+            <a:pPr indent="0" lvl="0" marL="44450" rtl="0" algn="l">
+              <a:lnSpc>
+                <a:spcPct val="100000"/>
+              </a:lnSpc>
+              <a:spcBef>
+                <a:spcPts val="0"/>
+              </a:spcBef>
+              <a:spcAft>
+                <a:spcPts val="0"/>
+              </a:spcAft>
+              <a:buClr>
+                <a:srgbClr val="888888"/>
+              </a:buClr>
+              <a:buSzPts val="2000"/>
+              <a:buFont typeface="Arial"/>
+              <a:buNone/>
+            </a:pPr>
+            <a:r>
+              <a:t/>
+            </a:r>
+            <a:endParaRPr/>
+          </a:p>
+        </p:txBody>
+      </p:sp>
+    </p:spTree>
+  </p:cSld>
+  <p:clrMapOvr>
+    <a:masterClrMapping/>
+  </p:clrMapOvr>
+</p:sld>
+</file>
+
+<file path=ppt/slides/slide22.xml><?xml version="1.0" encoding="utf-8"?>
+<p:sld xmlns:a="http://schemas.openxmlformats.org/drawingml/2006/main" xmlns:r="http://schemas.openxmlformats.org/officeDocument/2006/relationships" xmlns:mc="http://schemas.openxmlformats.org/markup-compatibility/2006" xmlns:mv="urn:schemas-microsoft-com:mac:vml" xmlns:p="http://schemas.openxmlformats.org/presentationml/2006/main" xmlns:c="http://schemas.openxmlformats.org/drawingml/2006/chart" xmlns:dgm="http://schemas.openxmlformats.org/drawingml/2006/diagram" xmlns:o="urn:schemas-microsoft-com:office:office" xmlns:v="urn:schemas-microsoft-com:vml" xmlns:pvml="urn:schemas-microsoft-com:office:powerpoint" xmlns:com="http://schemas.openxmlformats.org/drawingml/2006/compatibility" xmlns:p14="http://schemas.microsoft.com/office/powerpoint/2010/main" xmlns:p15="http://schemas.microsoft.com/office/powerpoint/2012/main" xmlns:ahyp="http://schemas.microsoft.com/office/drawing/2018/hyperlinkcolor">
+  <p:cSld>
+    <p:spTree>
+      <p:nvGrpSpPr>
+        <p:cNvPr id="270" name="Shape 270"/>
+        <p:cNvGrpSpPr/>
+        <p:nvPr/>
+      </p:nvGrpSpPr>
+      <p:grpSpPr>
+        <a:xfrm>
+          <a:off x="0" y="0"/>
+          <a:ext cx="0" cy="0"/>
+          <a:chOff x="0" y="0"/>
+          <a:chExt cx="0" cy="0"/>
+        </a:xfrm>
+      </p:grpSpPr>
+      <p:sp>
+        <p:nvSpPr>
+          <p:cNvPr id="271" name="Google Shape;271;p34"/>
           <p:cNvSpPr txBox="1"/>
           <p:nvPr>
             <p:ph type="title"/>
@@ -22241,7 +22548,11 @@
               <a:spcAft>
                 <a:spcPts val="0"/>
               </a:spcAft>
-              <a:buSzPts val="1400"/>
+              <a:buClr>
+                <a:schemeClr val="dk1"/>
+              </a:buClr>
+              <a:buSzPts val="1400"/>
+              <a:buFont typeface="Arial"/>
               <a:buNone/>
             </a:pPr>
             <a:r>
@@ -22258,7 +22569,7 @@
       </p:sp>
       <p:sp>
         <p:nvSpPr>
-          <p:cNvPr id="267" name="Google Shape;267;p33"/>
+          <p:cNvPr id="272" name="Google Shape;272;p34"/>
           <p:cNvSpPr txBox="1"/>
           <p:nvPr/>
         </p:nvSpPr>
@@ -22281,12 +22592,12 @@
           </a:bodyPr>
           <a:lstStyle/>
           <a:p>
-            <a:pPr indent="0" lvl="0" marL="0" rtl="0" algn="l">
+            <a:pPr indent="0" lvl="0" marL="0" rtl="0" algn="just">
               <a:lnSpc>
                 <a:spcPct val="150000"/>
               </a:lnSpc>
               <a:spcBef>
-                <a:spcPts val="1200"/>
+                <a:spcPts val="0"/>
               </a:spcBef>
               <a:spcAft>
                 <a:spcPts val="0"/>
@@ -22299,44 +22610,115 @@
               <a:buNone/>
             </a:pPr>
             <a:r>
-              <a:rPr b="1" lang="en-US" sz="2000">
+              <a:rPr b="1" lang="en-US" sz="1800">
+                <a:solidFill>
+                  <a:srgbClr val="0B3D59"/>
+                </a:solidFill>
+                <a:latin typeface="Calibri"/>
+                <a:ea typeface="Calibri"/>
+                <a:cs typeface="Calibri"/>
+                <a:sym typeface="Calibri"/>
+              </a:rPr>
+              <a:t>Phase 1: Proposal &amp; Literature Foundation (Weeks 1–4)</a:t>
+            </a:r>
+            <a:br>
+              <a:rPr b="1" lang="en-US" sz="1800">
                 <a:solidFill>
                   <a:schemeClr val="dk1"/>
                 </a:solidFill>
+                <a:latin typeface="Calibri"/>
+                <a:ea typeface="Calibri"/>
+                <a:cs typeface="Calibri"/>
+                <a:sym typeface="Calibri"/>
               </a:rPr>
-              <a:t>Phase 4: Uncertainty &amp; Explainability:</a:t>
-            </a:r>
+            </a:br>
             <a:r>
-              <a:rPr lang="en-US" sz="2000">
+              <a:rPr lang="en-US" sz="1800">
                 <a:solidFill>
                   <a:schemeClr val="dk1"/>
                 </a:solidFill>
+                <a:latin typeface="Calibri"/>
+                <a:ea typeface="Calibri"/>
+                <a:cs typeface="Calibri"/>
+                <a:sym typeface="Calibri"/>
               </a:rPr>
-              <a:t> Weeks 11-13</a:t>
+              <a:t>Finalize literature review, gap analysis, problem statement. Build and deliver proposal presentation.</a:t>
+            </a:r>
+            <a:endParaRPr i="1" sz="1800">
+              <a:solidFill>
+                <a:schemeClr val="dk1"/>
+              </a:solidFill>
+              <a:latin typeface="Calibri"/>
+              <a:ea typeface="Calibri"/>
+              <a:cs typeface="Calibri"/>
+              <a:sym typeface="Calibri"/>
+            </a:endParaRPr>
+          </a:p>
+          <a:p>
+            <a:pPr indent="0" lvl="0" marL="0" rtl="0" algn="just">
+              <a:lnSpc>
+                <a:spcPct val="150000"/>
+              </a:lnSpc>
+              <a:spcBef>
+                <a:spcPts val="1200"/>
+              </a:spcBef>
+              <a:spcAft>
+                <a:spcPts val="0"/>
+              </a:spcAft>
+              <a:buClr>
+                <a:schemeClr val="dk1"/>
+              </a:buClr>
+              <a:buSzPts val="1100"/>
+              <a:buFont typeface="Arial"/>
+              <a:buNone/>
+            </a:pPr>
+            <a:r>
+              <a:rPr b="1" lang="en-US" sz="1800">
+                <a:solidFill>
+                  <a:srgbClr val="0B3D59"/>
+                </a:solidFill>
+                <a:latin typeface="Calibri"/>
+                <a:ea typeface="Calibri"/>
+                <a:cs typeface="Calibri"/>
+                <a:sym typeface="Calibri"/>
+              </a:rPr>
+              <a:t>Phase 2: Data Pipeline &amp; Preprocessing (Weeks 5–7)</a:t>
             </a:r>
             <a:br>
-              <a:rPr lang="en-US" sz="2000">
+              <a:rPr b="1" lang="en-US" sz="1800">
                 <a:solidFill>
                   <a:schemeClr val="dk1"/>
                 </a:solidFill>
+                <a:latin typeface="Calibri"/>
+                <a:ea typeface="Calibri"/>
+                <a:cs typeface="Calibri"/>
+                <a:sym typeface="Calibri"/>
               </a:rPr>
             </a:br>
             <a:r>
-              <a:rPr lang="en-US" sz="2000">
+              <a:rPr lang="en-US" sz="1800">
                 <a:solidFill>
                   <a:schemeClr val="dk1"/>
                 </a:solidFill>
+                <a:latin typeface="Calibri"/>
+                <a:ea typeface="Calibri"/>
+                <a:cs typeface="Calibri"/>
+                <a:sym typeface="Calibri"/>
               </a:rPr>
-              <a:t>Integrate Monte Carlo Dropout for confidence estimation. Implement attention-based explainability. Add missing-modality robustness handling.</a:t>
+              <a:t>Collect and standardize all five modality datasets. Address class imbalance. Build train/validation/test splits.</a:t>
             </a:r>
-            <a:endParaRPr sz="2000">
+            <a:endParaRPr sz="1800">
               <a:solidFill>
                 <a:schemeClr val="dk1"/>
               </a:solidFill>
+              <a:latin typeface="Calibri"/>
+              <a:ea typeface="Calibri"/>
+              <a:cs typeface="Calibri"/>
+              <a:sym typeface="Calibri"/>
             </a:endParaRPr>
           </a:p>
           <a:p>
-            <a:pPr indent="0" lvl="0" marL="0" rtl="0" algn="l">
+            <a:pPr indent="0" lvl="0" marL="0" rtl="0" algn="just">
               <a:lnSpc>
                 <a:spcPct val="150000"/>
               </a:lnSpc>
@@ -22354,44 +22736,52 @@
               <a:buNone/>
             </a:pPr>
             <a:r>
-              <a:rPr b="1" lang="en-US" sz="2000">
+              <a:rPr b="1" lang="en-US" sz="1800">
+                <a:solidFill>
+                  <a:srgbClr val="0B3D59"/>
+                </a:solidFill>
+                <a:latin typeface="Calibri"/>
+                <a:ea typeface="Calibri"/>
+                <a:cs typeface="Calibri"/>
+                <a:sym typeface="Calibri"/>
+              </a:rPr>
+              <a:t>Phase 3: Encoder &amp; Fusion Development (Weeks 8–10)</a:t>
+            </a:r>
+            <a:br>
+              <a:rPr b="1" lang="en-US" sz="1800">
+                <a:solidFill>
+                  <a:srgbClr val="0B3D59"/>
+                </a:solidFill>
+                <a:latin typeface="Calibri"/>
+                <a:ea typeface="Calibri"/>
+                <a:cs typeface="Calibri"/>
+                <a:sym typeface="Calibri"/>
+              </a:rPr>
+            </a:br>
+            <a:r>
+              <a:rPr lang="en-US" sz="1800">
                 <a:solidFill>
                   <a:schemeClr val="dk1"/>
                 </a:solidFill>
+                <a:latin typeface="Calibri"/>
+                <a:ea typeface="Calibri"/>
+                <a:cs typeface="Calibri"/>
+                <a:sym typeface="Calibri"/>
               </a:rPr>
-              <a:t>Phase 5: Evaluation &amp; Report Generation:</a:t>
+              <a:t>Train five ViT-B/16 specialist encoders. Implement the cross-modal attention fusion transformer, designed to handle a missing modality input. Begin mobile app development in parallel.</a:t>
             </a:r>
-            <a:r>
-              <a:rPr lang="en-US" sz="2000">
-                <a:solidFill>
-                  <a:schemeClr val="dk1"/>
-                </a:solidFill>
-              </a:rPr>
-              <a:t> Weeks 14-16</a:t>
-            </a:r>
-            <a:br>
-              <a:rPr lang="en-US" sz="2000">
-                <a:solidFill>
-                  <a:schemeClr val="dk1"/>
-                </a:solidFill>
-              </a:rPr>
-            </a:br>
-            <a:r>
-              <a:rPr lang="en-US" sz="2000">
-                <a:solidFill>
-                  <a:schemeClr val="dk1"/>
-                </a:solidFill>
-              </a:rPr>
-              <a:t>Benchmark against literature baselines. Build the LLM patient-report module. Finalize documentation.</a:t>
-            </a:r>
-            <a:endParaRPr i="1" sz="2000">
+            <a:endParaRPr sz="1800">
               <a:solidFill>
                 <a:schemeClr val="dk1"/>
               </a:solidFill>
+              <a:latin typeface="Calibri"/>
+              <a:ea typeface="Calibri"/>
+              <a:cs typeface="Calibri"/>
+              <a:sym typeface="Calibri"/>
             </a:endParaRPr>
           </a:p>
           <a:p>
-            <a:pPr indent="0" lvl="0" marL="0" rtl="0" algn="l">
+            <a:pPr indent="0" lvl="0" marL="0" rtl="0" algn="just">
               <a:lnSpc>
                 <a:spcPct val="150000"/>
               </a:lnSpc>
@@ -22399,50 +22789,21 @@
                 <a:spcPts val="1200"/>
               </a:spcBef>
               <a:spcAft>
-                <a:spcPts val="1200"/>
-              </a:spcAft>
-              <a:buClr>
-                <a:schemeClr val="dk1"/>
-              </a:buClr>
-              <a:buSzPts val="1100"/>
-              <a:buFont typeface="Arial"/>
+                <a:spcPts val="0"/>
+              </a:spcAft>
               <a:buNone/>
             </a:pPr>
             <a:r>
-              <a:rPr b="1" lang="en-US" sz="2000">
-                <a:solidFill>
-                  <a:schemeClr val="dk1"/>
-                </a:solidFill>
-              </a:rPr>
-              <a:t>Phase 6: Part 1 Defense Prep:</a:t>
+              <a:t/>
             </a:r>
-            <a:r>
-              <a:rPr lang="en-US" sz="2000">
-                <a:solidFill>
-                  <a:schemeClr val="dk1"/>
-                </a:solidFill>
-              </a:rPr>
-              <a:t> After Finals</a:t>
-            </a:r>
-            <a:br>
-              <a:rPr lang="en-US" sz="2000">
-                <a:solidFill>
-                  <a:schemeClr val="dk1"/>
-                </a:solidFill>
-              </a:rPr>
-            </a:br>
-            <a:r>
-              <a:rPr lang="en-US" sz="2000">
-                <a:solidFill>
-                  <a:schemeClr val="dk1"/>
-                </a:solidFill>
-              </a:rPr>
-              <a:t>Rehearse and deliver Part 1 Defense</a:t>
-            </a:r>
-            <a:endParaRPr b="1" sz="2000">
+            <a:endParaRPr b="1" sz="2700">
               <a:solidFill>
                 <a:schemeClr val="dk1"/>
               </a:solidFill>
+              <a:latin typeface="Calibri"/>
+              <a:ea typeface="Calibri"/>
+              <a:cs typeface="Calibri"/>
+              <a:sym typeface="Calibri"/>
             </a:endParaRPr>
           </a:p>
         </p:txBody>
@@ -22455,12 +22816,12 @@
 </p:sld>
 </file>
 
-<file path=ppt/slides/slide22.xml><?xml version="1.0" encoding="utf-8"?>
+<file path=ppt/slides/slide23.xml><?xml version="1.0" encoding="utf-8"?>
 <p:sld xmlns:a="http://schemas.openxmlformats.org/drawingml/2006/main" xmlns:r="http://schemas.openxmlformats.org/officeDocument/2006/relationships" xmlns:mc="http://schemas.openxmlformats.org/markup-compatibility/2006" xmlns:mv="urn:schemas-microsoft-com:mac:vml" xmlns:p="http://schemas.openxmlformats.org/presentationml/2006/main" xmlns:c="http://schemas.openxmlformats.org/drawingml/2006/chart" xmlns:dgm="http://schemas.openxmlformats.org/drawingml/2006/diagram" xmlns:o="urn:schemas-microsoft-com:office:office" xmlns:v="urn:schemas-microsoft-com:vml" xmlns:pvml="urn:schemas-microsoft-com:office:powerpoint" xmlns:com="http://schemas.openxmlformats.org/drawingml/2006/compatibility" xmlns:p14="http://schemas.microsoft.com/office/powerpoint/2010/main" xmlns:p15="http://schemas.microsoft.com/office/powerpoint/2012/main" xmlns:ahyp="http://schemas.microsoft.com/office/drawing/2018/hyperlinkcolor">
   <p:cSld>
     <p:spTree>
       <p:nvGrpSpPr>
-        <p:cNvPr id="271" name="Shape 271"/>
+        <p:cNvPr id="276" name="Shape 276"/>
         <p:cNvGrpSpPr/>
         <p:nvPr/>
       </p:nvGrpSpPr>
@@ -22474,7 +22835,296 @@
       </p:grpSpPr>
       <p:sp>
         <p:nvSpPr>
-          <p:cNvPr id="272" name="Google Shape;272;p34"/>
+          <p:cNvPr id="277" name="Google Shape;277;p35"/>
+          <p:cNvSpPr txBox="1"/>
+          <p:nvPr>
+            <p:ph type="title"/>
+          </p:nvPr>
+        </p:nvSpPr>
+        <p:spPr>
+          <a:xfrm>
+            <a:off x="457200" y="274638"/>
+            <a:ext cx="8229600" cy="1143000"/>
+          </a:xfrm>
+          <a:prstGeom prst="rect">
+            <a:avLst/>
+          </a:prstGeom>
+          <a:noFill/>
+          <a:ln>
+            <a:noFill/>
+          </a:ln>
+        </p:spPr>
+        <p:txBody>
+          <a:bodyPr anchorCtr="0" anchor="ctr" bIns="45700" lIns="91425" spcFirstLastPara="1" rIns="91425" wrap="square" tIns="45700">
+            <a:noAutofit/>
+          </a:bodyPr>
+          <a:lstStyle/>
+          <a:p>
+            <a:pPr indent="0" lvl="0" marL="0" rtl="0" algn="ctr">
+              <a:spcBef>
+                <a:spcPts val="0"/>
+              </a:spcBef>
+              <a:spcAft>
+                <a:spcPts val="0"/>
+              </a:spcAft>
+              <a:buSzPts val="1400"/>
+              <a:buNone/>
+            </a:pPr>
+            <a:r>
+              <a:rPr b="1" lang="en-US" sz="4000">
+                <a:solidFill>
+                  <a:srgbClr val="0B3D59"/>
+                </a:solidFill>
+              </a:rPr>
+              <a:t>Work Breakdown</a:t>
+            </a:r>
+            <a:endParaRPr/>
+          </a:p>
+        </p:txBody>
+      </p:sp>
+      <p:sp>
+        <p:nvSpPr>
+          <p:cNvPr id="278" name="Google Shape;278;p35"/>
+          <p:cNvSpPr txBox="1"/>
+          <p:nvPr/>
+        </p:nvSpPr>
+        <p:spPr>
+          <a:xfrm>
+            <a:off x="342900" y="1418725"/>
+            <a:ext cx="8343900" cy="4292700"/>
+          </a:xfrm>
+          <a:prstGeom prst="rect">
+            <a:avLst/>
+          </a:prstGeom>
+          <a:noFill/>
+          <a:ln>
+            <a:noFill/>
+          </a:ln>
+        </p:spPr>
+        <p:txBody>
+          <a:bodyPr anchorCtr="0" anchor="t" bIns="91425" lIns="91425" spcFirstLastPara="1" rIns="91425" wrap="square" tIns="91425">
+            <a:noAutofit/>
+          </a:bodyPr>
+          <a:lstStyle/>
+          <a:p>
+            <a:pPr indent="0" lvl="0" marL="0" rtl="0" algn="just">
+              <a:lnSpc>
+                <a:spcPct val="150000"/>
+              </a:lnSpc>
+              <a:spcBef>
+                <a:spcPts val="1200"/>
+              </a:spcBef>
+              <a:spcAft>
+                <a:spcPts val="0"/>
+              </a:spcAft>
+              <a:buClr>
+                <a:schemeClr val="dk1"/>
+              </a:buClr>
+              <a:buSzPts val="1100"/>
+              <a:buFont typeface="Arial"/>
+              <a:buNone/>
+            </a:pPr>
+            <a:r>
+              <a:rPr b="1" lang="en-US" sz="1800">
+                <a:solidFill>
+                  <a:srgbClr val="0B3D59"/>
+                </a:solidFill>
+                <a:latin typeface="Calibri"/>
+                <a:ea typeface="Calibri"/>
+                <a:cs typeface="Calibri"/>
+                <a:sym typeface="Calibri"/>
+              </a:rPr>
+              <a:t>Phase 4: Model Testing &amp; App Integration (Weeks 11–13)</a:t>
+            </a:r>
+            <a:br>
+              <a:rPr b="1" lang="en-US" sz="1800">
+                <a:solidFill>
+                  <a:schemeClr val="dk1"/>
+                </a:solidFill>
+                <a:latin typeface="Calibri"/>
+                <a:ea typeface="Calibri"/>
+                <a:cs typeface="Calibri"/>
+                <a:sym typeface="Calibri"/>
+              </a:rPr>
+            </a:br>
+            <a:r>
+              <a:rPr lang="en-US" sz="1800">
+                <a:solidFill>
+                  <a:schemeClr val="dk1"/>
+                </a:solidFill>
+                <a:latin typeface="Calibri"/>
+                <a:ea typeface="Calibri"/>
+                <a:cs typeface="Calibri"/>
+                <a:sym typeface="Calibri"/>
+              </a:rPr>
+              <a:t>Full model training and evaluation. Continue app development, connect app to the model pipeline end-to-end.</a:t>
+            </a:r>
+            <a:endParaRPr sz="1800">
+              <a:solidFill>
+                <a:schemeClr val="dk1"/>
+              </a:solidFill>
+              <a:latin typeface="Calibri"/>
+              <a:ea typeface="Calibri"/>
+              <a:cs typeface="Calibri"/>
+              <a:sym typeface="Calibri"/>
+            </a:endParaRPr>
+          </a:p>
+          <a:p>
+            <a:pPr indent="0" lvl="0" marL="0" rtl="0" algn="just">
+              <a:lnSpc>
+                <a:spcPct val="150000"/>
+              </a:lnSpc>
+              <a:spcBef>
+                <a:spcPts val="1200"/>
+              </a:spcBef>
+              <a:spcAft>
+                <a:spcPts val="0"/>
+              </a:spcAft>
+              <a:buClr>
+                <a:schemeClr val="dk1"/>
+              </a:buClr>
+              <a:buSzPts val="1100"/>
+              <a:buFont typeface="Arial"/>
+              <a:buNone/>
+            </a:pPr>
+            <a:r>
+              <a:rPr b="1" lang="en-US" sz="1800">
+                <a:solidFill>
+                  <a:srgbClr val="0B3D59"/>
+                </a:solidFill>
+                <a:latin typeface="Calibri"/>
+                <a:ea typeface="Calibri"/>
+                <a:cs typeface="Calibri"/>
+                <a:sym typeface="Calibri"/>
+              </a:rPr>
+              <a:t>Phase 5: Integration, Testing &amp; Documentation (Weeks 14–16)</a:t>
+            </a:r>
+            <a:br>
+              <a:rPr b="1" lang="en-US" sz="1800">
+                <a:solidFill>
+                  <a:srgbClr val="0B3D59"/>
+                </a:solidFill>
+                <a:latin typeface="Calibri"/>
+                <a:ea typeface="Calibri"/>
+                <a:cs typeface="Calibri"/>
+                <a:sym typeface="Calibri"/>
+              </a:rPr>
+            </a:br>
+            <a:r>
+              <a:rPr lang="en-US" sz="1800">
+                <a:solidFill>
+                  <a:schemeClr val="dk1"/>
+                </a:solidFill>
+                <a:latin typeface="Calibri"/>
+                <a:ea typeface="Calibri"/>
+                <a:cs typeface="Calibri"/>
+                <a:sym typeface="Calibri"/>
+              </a:rPr>
+              <a:t>Final integration testing between app and model. Benchmark against literature baselines. Finalize documentation.</a:t>
+            </a:r>
+            <a:endParaRPr sz="1800">
+              <a:solidFill>
+                <a:schemeClr val="dk1"/>
+              </a:solidFill>
+              <a:latin typeface="Calibri"/>
+              <a:ea typeface="Calibri"/>
+              <a:cs typeface="Calibri"/>
+              <a:sym typeface="Calibri"/>
+            </a:endParaRPr>
+          </a:p>
+          <a:p>
+            <a:pPr indent="0" lvl="0" marL="0" rtl="0" algn="just">
+              <a:lnSpc>
+                <a:spcPct val="150000"/>
+              </a:lnSpc>
+              <a:spcBef>
+                <a:spcPts val="1200"/>
+              </a:spcBef>
+              <a:spcAft>
+                <a:spcPts val="1200"/>
+              </a:spcAft>
+              <a:buClr>
+                <a:schemeClr val="dk1"/>
+              </a:buClr>
+              <a:buSzPts val="1100"/>
+              <a:buFont typeface="Arial"/>
+              <a:buNone/>
+            </a:pPr>
+            <a:r>
+              <a:rPr b="1" lang="en-US" sz="1800">
+                <a:solidFill>
+                  <a:srgbClr val="0B3D59"/>
+                </a:solidFill>
+                <a:latin typeface="Calibri"/>
+                <a:ea typeface="Calibri"/>
+                <a:cs typeface="Calibri"/>
+                <a:sym typeface="Calibri"/>
+              </a:rPr>
+              <a:t>Phase 6: Part 1 Defense Prep (After Finals)</a:t>
+            </a:r>
+            <a:br>
+              <a:rPr b="1" lang="en-US" sz="1800">
+                <a:solidFill>
+                  <a:schemeClr val="dk1"/>
+                </a:solidFill>
+                <a:latin typeface="Calibri"/>
+                <a:ea typeface="Calibri"/>
+                <a:cs typeface="Calibri"/>
+                <a:sym typeface="Calibri"/>
+              </a:rPr>
+            </a:br>
+            <a:r>
+              <a:rPr lang="en-US" sz="1800">
+                <a:solidFill>
+                  <a:schemeClr val="dk1"/>
+                </a:solidFill>
+                <a:latin typeface="Calibri"/>
+                <a:ea typeface="Calibri"/>
+                <a:cs typeface="Calibri"/>
+                <a:sym typeface="Calibri"/>
+              </a:rPr>
+              <a:t>Rehearse and deliver Part 1 Defense.</a:t>
+            </a:r>
+            <a:endParaRPr b="1" sz="1800">
+              <a:solidFill>
+                <a:schemeClr val="dk1"/>
+              </a:solidFill>
+              <a:latin typeface="Calibri"/>
+              <a:ea typeface="Calibri"/>
+              <a:cs typeface="Calibri"/>
+              <a:sym typeface="Calibri"/>
+            </a:endParaRPr>
+          </a:p>
+        </p:txBody>
+      </p:sp>
+    </p:spTree>
+  </p:cSld>
+  <p:clrMapOvr>
+    <a:masterClrMapping/>
+  </p:clrMapOvr>
+</p:sld>
+</file>
+
+<file path=ppt/slides/slide24.xml><?xml version="1.0" encoding="utf-8"?>
+<p:sld xmlns:a="http://schemas.openxmlformats.org/drawingml/2006/main" xmlns:r="http://schemas.openxmlformats.org/officeDocument/2006/relationships" xmlns:mc="http://schemas.openxmlformats.org/markup-compatibility/2006" xmlns:mv="urn:schemas-microsoft-com:mac:vml" xmlns:p="http://schemas.openxmlformats.org/presentationml/2006/main" xmlns:c="http://schemas.openxmlformats.org/drawingml/2006/chart" xmlns:dgm="http://schemas.openxmlformats.org/drawingml/2006/diagram" xmlns:o="urn:schemas-microsoft-com:office:office" xmlns:v="urn:schemas-microsoft-com:vml" xmlns:pvml="urn:schemas-microsoft-com:office:powerpoint" xmlns:com="http://schemas.openxmlformats.org/drawingml/2006/compatibility" xmlns:p14="http://schemas.microsoft.com/office/powerpoint/2010/main" xmlns:p15="http://schemas.microsoft.com/office/powerpoint/2012/main" xmlns:ahyp="http://schemas.microsoft.com/office/drawing/2018/hyperlinkcolor">
+  <p:cSld>
+    <p:spTree>
+      <p:nvGrpSpPr>
+        <p:cNvPr id="282" name="Shape 282"/>
+        <p:cNvGrpSpPr/>
+        <p:nvPr/>
+      </p:nvGrpSpPr>
+      <p:grpSpPr>
+        <a:xfrm>
+          <a:off x="0" y="0"/>
+          <a:ext cx="0" cy="0"/>
+          <a:chOff x="0" y="0"/>
+          <a:chExt cx="0" cy="0"/>
+        </a:xfrm>
+      </p:grpSpPr>
+      <p:sp>
+        <p:nvSpPr>
+          <p:cNvPr id="283" name="Google Shape;283;p36"/>
           <p:cNvSpPr txBox="1"/>
           <p:nvPr>
             <p:ph type="title"/>
@@ -22523,7 +23173,7 @@
       </p:sp>
       <p:sp>
         <p:nvSpPr>
-          <p:cNvPr id="273" name="Google Shape;273;p34"/>
+          <p:cNvPr id="284" name="Google Shape;284;p36"/>
           <p:cNvSpPr txBox="1"/>
           <p:nvPr>
             <p:ph idx="1" type="body"/>
@@ -22580,12 +23230,12 @@
 </p:sld>
 </file>
 
-<file path=ppt/slides/slide23.xml><?xml version="1.0" encoding="utf-8"?>
+<file path=ppt/slides/slide25.xml><?xml version="1.0" encoding="utf-8"?>
 <p:sld xmlns:a="http://schemas.openxmlformats.org/drawingml/2006/main" xmlns:r="http://schemas.openxmlformats.org/officeDocument/2006/relationships" xmlns:mc="http://schemas.openxmlformats.org/markup-compatibility/2006" xmlns:mv="urn:schemas-microsoft-com:mac:vml" xmlns:p="http://schemas.openxmlformats.org/presentationml/2006/main" xmlns:c="http://schemas.openxmlformats.org/drawingml/2006/chart" xmlns:dgm="http://schemas.openxmlformats.org/drawingml/2006/diagram" xmlns:o="urn:schemas-microsoft-com:office:office" xmlns:v="urn:schemas-microsoft-com:vml" xmlns:pvml="urn:schemas-microsoft-com:office:powerpoint" xmlns:com="http://schemas.openxmlformats.org/drawingml/2006/compatibility" xmlns:p14="http://schemas.microsoft.com/office/powerpoint/2010/main" xmlns:p15="http://schemas.microsoft.com/office/powerpoint/2012/main" xmlns:ahyp="http://schemas.microsoft.com/office/drawing/2018/hyperlinkcolor">
   <p:cSld>
     <p:spTree>
       <p:nvGrpSpPr>
-        <p:cNvPr id="277" name="Shape 277"/>
+        <p:cNvPr id="288" name="Shape 288"/>
         <p:cNvGrpSpPr/>
         <p:nvPr/>
       </p:nvGrpSpPr>
@@ -22599,7 +23249,7 @@
       </p:grpSpPr>
       <p:sp>
         <p:nvSpPr>
-          <p:cNvPr id="278" name="Google Shape;278;p35"/>
+          <p:cNvPr id="289" name="Google Shape;289;p37"/>
           <p:cNvSpPr txBox="1"/>
           <p:nvPr>
             <p:ph type="title"/>
@@ -22655,7 +23305,7 @@
       </p:sp>
       <p:graphicFrame>
         <p:nvGraphicFramePr>
-          <p:cNvPr id="279" name="Google Shape;279;p35"/>
+          <p:cNvPr id="290" name="Google Shape;290;p37"/>
           <p:cNvGraphicFramePr/>
           <p:nvPr/>
         </p:nvGraphicFramePr>
@@ -22668,7 +23318,7 @@
             <a:tbl>
               <a:tblPr>
                 <a:noFill/>
-                <a:tableStyleId>{A86E29F2-8678-437A-8A81-A00D8066E49F}</a:tableStyleId>
+                <a:tableStyleId>{6DCBE433-D38A-414C-8CE7-A03D4E96D332}</a:tableStyleId>
               </a:tblPr>
               <a:tblGrid>
                 <a:gridCol w="2720975"/>
@@ -22804,6 +23454,135 @@
                       <a:srgbClr val="1C7293"/>
                     </a:solidFill>
                   </a:tcPr>
+                </a:tc>
+              </a:tr>
+              <a:tr h="1627200">
+                <a:tc>
+                  <a:txBody>
+                    <a:bodyPr/>
+                    <a:lstStyle/>
+                    <a:p>
+                      <a:pPr indent="0" lvl="0" marL="0" rtl="0" algn="l">
+                        <a:lnSpc>
+                          <a:spcPct val="150000"/>
+                        </a:lnSpc>
+                        <a:spcBef>
+                          <a:spcPts val="0"/>
+                        </a:spcBef>
+                        <a:spcAft>
+                          <a:spcPts val="0"/>
+                        </a:spcAft>
+                        <a:buNone/>
+                      </a:pPr>
+                      <a:r>
+                        <a:rPr b="1" lang="en-US" sz="1800">
+                          <a:solidFill>
+                            <a:schemeClr val="dk1"/>
+                          </a:solidFill>
+                          <a:latin typeface="Calibri"/>
+                          <a:ea typeface="Calibri"/>
+                          <a:cs typeface="Calibri"/>
+                          <a:sym typeface="Calibri"/>
+                        </a:rPr>
+                        <a:t>Sir Islam Abbasi</a:t>
+                      </a:r>
+                      <a:endParaRPr b="1" sz="1800">
+                        <a:latin typeface="Calibri"/>
+                        <a:ea typeface="Calibri"/>
+                        <a:cs typeface="Calibri"/>
+                        <a:sym typeface="Calibri"/>
+                      </a:endParaRPr>
+                    </a:p>
+                  </a:txBody>
+                  <a:tcPr marT="91425" marB="91425" marR="91425" marL="91425"/>
+                </a:tc>
+                <a:tc>
+                  <a:txBody>
+                    <a:bodyPr/>
+                    <a:lstStyle/>
+                    <a:p>
+                      <a:pPr indent="0" lvl="0" marL="0" rtl="0" algn="l">
+                        <a:lnSpc>
+                          <a:spcPct val="150000"/>
+                        </a:lnSpc>
+                        <a:spcBef>
+                          <a:spcPts val="0"/>
+                        </a:spcBef>
+                        <a:spcAft>
+                          <a:spcPts val="0"/>
+                        </a:spcAft>
+                        <a:buClr>
+                          <a:schemeClr val="dk1"/>
+                        </a:buClr>
+                        <a:buSzPts val="1100"/>
+                        <a:buFont typeface="Arial"/>
+                        <a:buNone/>
+                      </a:pPr>
+                      <a:r>
+                        <a:rPr lang="en-US" sz="1800">
+                          <a:solidFill>
+                            <a:schemeClr val="dk1"/>
+                          </a:solidFill>
+                          <a:latin typeface="Calibri"/>
+                          <a:ea typeface="Calibri"/>
+                          <a:cs typeface="Calibri"/>
+                          <a:sym typeface="Calibri"/>
+                        </a:rPr>
+                        <a:t>Project Supervisor</a:t>
+                      </a:r>
+                      <a:endParaRPr sz="1800">
+                        <a:latin typeface="Calibri"/>
+                        <a:ea typeface="Calibri"/>
+                        <a:cs typeface="Calibri"/>
+                        <a:sym typeface="Calibri"/>
+                      </a:endParaRPr>
+                    </a:p>
+                  </a:txBody>
+                  <a:tcPr marT="91425" marB="91425" marR="91425" marL="91425"/>
+                </a:tc>
+                <a:tc>
+                  <a:txBody>
+                    <a:bodyPr/>
+                    <a:lstStyle/>
+                    <a:p>
+                      <a:pPr indent="0" lvl="0" marL="0" rtl="0" algn="l">
+                        <a:lnSpc>
+                          <a:spcPct val="150000"/>
+                        </a:lnSpc>
+                        <a:spcBef>
+                          <a:spcPts val="0"/>
+                        </a:spcBef>
+                        <a:spcAft>
+                          <a:spcPts val="0"/>
+                        </a:spcAft>
+                        <a:buClr>
+                          <a:schemeClr val="dk1"/>
+                        </a:buClr>
+                        <a:buSzPts val="1100"/>
+                        <a:buFont typeface="Arial"/>
+                        <a:buNone/>
+                      </a:pPr>
+                      <a:r>
+                        <a:rPr lang="en-US" sz="1800">
+                          <a:solidFill>
+                            <a:schemeClr val="dk1"/>
+                          </a:solidFill>
+                          <a:latin typeface="Calibri"/>
+                          <a:ea typeface="Calibri"/>
+                          <a:cs typeface="Calibri"/>
+                          <a:sym typeface="Calibri"/>
+                        </a:rPr>
+                        <a:t>Provides technical guidance, reviews progress at each milestone, approves scope and methodology decisions</a:t>
+                      </a:r>
+                      <a:endParaRPr sz="1800">
+                        <a:latin typeface="Calibri"/>
+                        <a:ea typeface="Calibri"/>
+                        <a:cs typeface="Calibri"/>
+                        <a:sym typeface="Calibri"/>
+                      </a:endParaRPr>
+                    </a:p>
+                  </a:txBody>
+                  <a:tcPr marT="91425" marB="91425" marR="91425" marL="91425"/>
                 </a:tc>
               </a:tr>
               <a:tr h="1627200">
@@ -22974,6 +23753,244 @@
                   <a:tcPr marT="91425" marB="91425" marR="91425" marL="91425"/>
                 </a:tc>
               </a:tr>
+            </a:tbl>
+          </a:graphicData>
+        </a:graphic>
+      </p:graphicFrame>
+    </p:spTree>
+  </p:cSld>
+  <p:clrMapOvr>
+    <a:masterClrMapping/>
+  </p:clrMapOvr>
+</p:sld>
+</file>
+
+<file path=ppt/slides/slide26.xml><?xml version="1.0" encoding="utf-8"?>
+<p:sld xmlns:a="http://schemas.openxmlformats.org/drawingml/2006/main" xmlns:r="http://schemas.openxmlformats.org/officeDocument/2006/relationships" xmlns:mc="http://schemas.openxmlformats.org/markup-compatibility/2006" xmlns:mv="urn:schemas-microsoft-com:mac:vml" xmlns:p="http://schemas.openxmlformats.org/presentationml/2006/main" xmlns:c="http://schemas.openxmlformats.org/drawingml/2006/chart" xmlns:dgm="http://schemas.openxmlformats.org/drawingml/2006/diagram" xmlns:o="urn:schemas-microsoft-com:office:office" xmlns:v="urn:schemas-microsoft-com:vml" xmlns:pvml="urn:schemas-microsoft-com:office:powerpoint" xmlns:com="http://schemas.openxmlformats.org/drawingml/2006/compatibility" xmlns:p14="http://schemas.microsoft.com/office/powerpoint/2010/main" xmlns:p15="http://schemas.microsoft.com/office/powerpoint/2012/main" xmlns:ahyp="http://schemas.microsoft.com/office/drawing/2018/hyperlinkcolor">
+  <p:cSld>
+    <p:spTree>
+      <p:nvGrpSpPr>
+        <p:cNvPr id="294" name="Shape 294"/>
+        <p:cNvGrpSpPr/>
+        <p:nvPr/>
+      </p:nvGrpSpPr>
+      <p:grpSpPr>
+        <a:xfrm>
+          <a:off x="0" y="0"/>
+          <a:ext cx="0" cy="0"/>
+          <a:chOff x="0" y="0"/>
+          <a:chExt cx="0" cy="0"/>
+        </a:xfrm>
+      </p:grpSpPr>
+      <p:sp>
+        <p:nvSpPr>
+          <p:cNvPr id="295" name="Google Shape;295;p38"/>
+          <p:cNvSpPr txBox="1"/>
+          <p:nvPr>
+            <p:ph type="title"/>
+          </p:nvPr>
+        </p:nvSpPr>
+        <p:spPr>
+          <a:xfrm>
+            <a:off x="457200" y="274638"/>
+            <a:ext cx="8229600" cy="1143000"/>
+          </a:xfrm>
+          <a:prstGeom prst="rect">
+            <a:avLst/>
+          </a:prstGeom>
+          <a:noFill/>
+          <a:ln>
+            <a:noFill/>
+          </a:ln>
+        </p:spPr>
+        <p:txBody>
+          <a:bodyPr anchorCtr="0" anchor="ctr" bIns="45700" lIns="91425" spcFirstLastPara="1" rIns="91425" wrap="square" tIns="45700">
+            <a:noAutofit/>
+          </a:bodyPr>
+          <a:lstStyle/>
+          <a:p>
+            <a:pPr indent="0" lvl="0" marL="0" rtl="0" algn="ctr">
+              <a:lnSpc>
+                <a:spcPct val="100000"/>
+              </a:lnSpc>
+              <a:spcBef>
+                <a:spcPts val="0"/>
+              </a:spcBef>
+              <a:spcAft>
+                <a:spcPts val="0"/>
+              </a:spcAft>
+              <a:buSzPts val="1400"/>
+              <a:buNone/>
+            </a:pPr>
+            <a:r>
+              <a:rPr lang="en-US">
+                <a:solidFill>
+                  <a:srgbClr val="0B3D59"/>
+                </a:solidFill>
+              </a:rPr>
+              <a:t>Roles &amp; Responsibilities</a:t>
+            </a:r>
+            <a:endParaRPr>
+              <a:solidFill>
+                <a:srgbClr val="0B3D59"/>
+              </a:solidFill>
+            </a:endParaRPr>
+          </a:p>
+        </p:txBody>
+      </p:sp>
+      <p:graphicFrame>
+        <p:nvGraphicFramePr>
+          <p:cNvPr id="296" name="Google Shape;296;p38"/>
+          <p:cNvGraphicFramePr/>
+          <p:nvPr/>
+        </p:nvGraphicFramePr>
+        <p:xfrm>
+          <a:off x="457200" y="1556325"/>
+          <a:ext cx="3000000" cy="3000000"/>
+        </p:xfrm>
+        <a:graphic>
+          <a:graphicData uri="http://schemas.openxmlformats.org/drawingml/2006/table">
+            <a:tbl>
+              <a:tblPr>
+                <a:noFill/>
+                <a:tableStyleId>{6DCBE433-D38A-414C-8CE7-A03D4E96D332}</a:tableStyleId>
+              </a:tblPr>
+              <a:tblGrid>
+                <a:gridCol w="2720975"/>
+                <a:gridCol w="2720975"/>
+                <a:gridCol w="2720975"/>
+              </a:tblGrid>
+              <a:tr h="469075">
+                <a:tc>
+                  <a:txBody>
+                    <a:bodyPr/>
+                    <a:lstStyle/>
+                    <a:p>
+                      <a:pPr indent="0" lvl="0" marL="0" rtl="0" algn="l">
+                        <a:spcBef>
+                          <a:spcPts val="0"/>
+                        </a:spcBef>
+                        <a:spcAft>
+                          <a:spcPts val="0"/>
+                        </a:spcAft>
+                        <a:buNone/>
+                      </a:pPr>
+                      <a:r>
+                        <a:rPr b="1" lang="en-US" sz="2000">
+                          <a:solidFill>
+                            <a:schemeClr val="lt1"/>
+                          </a:solidFill>
+                          <a:latin typeface="Calibri"/>
+                          <a:ea typeface="Calibri"/>
+                          <a:cs typeface="Calibri"/>
+                          <a:sym typeface="Calibri"/>
+                        </a:rPr>
+                        <a:t>Member</a:t>
+                      </a:r>
+                      <a:endParaRPr b="1" sz="2000">
+                        <a:solidFill>
+                          <a:schemeClr val="lt1"/>
+                        </a:solidFill>
+                        <a:latin typeface="Calibri"/>
+                        <a:ea typeface="Calibri"/>
+                        <a:cs typeface="Calibri"/>
+                        <a:sym typeface="Calibri"/>
+                      </a:endParaRPr>
+                    </a:p>
+                  </a:txBody>
+                  <a:tcPr marT="91425" marB="91425" marR="91425" marL="91425">
+                    <a:solidFill>
+                      <a:srgbClr val="1C7293"/>
+                    </a:solidFill>
+                  </a:tcPr>
+                </a:tc>
+                <a:tc>
+                  <a:txBody>
+                    <a:bodyPr/>
+                    <a:lstStyle/>
+                    <a:p>
+                      <a:pPr indent="0" lvl="0" marL="0" rtl="0" algn="l">
+                        <a:spcBef>
+                          <a:spcPts val="0"/>
+                        </a:spcBef>
+                        <a:spcAft>
+                          <a:spcPts val="0"/>
+                        </a:spcAft>
+                        <a:buNone/>
+                      </a:pPr>
+                      <a:r>
+                        <a:rPr b="1" lang="en-US" sz="2000">
+                          <a:solidFill>
+                            <a:schemeClr val="lt1"/>
+                          </a:solidFill>
+                          <a:latin typeface="Calibri"/>
+                          <a:ea typeface="Calibri"/>
+                          <a:cs typeface="Calibri"/>
+                          <a:sym typeface="Calibri"/>
+                        </a:rPr>
+                        <a:t>Role</a:t>
+                      </a:r>
+                      <a:endParaRPr b="1" sz="2000">
+                        <a:solidFill>
+                          <a:schemeClr val="lt1"/>
+                        </a:solidFill>
+                        <a:latin typeface="Calibri"/>
+                        <a:ea typeface="Calibri"/>
+                        <a:cs typeface="Calibri"/>
+                        <a:sym typeface="Calibri"/>
+                      </a:endParaRPr>
+                    </a:p>
+                  </a:txBody>
+                  <a:tcPr marT="91425" marB="91425" marR="91425" marL="91425">
+                    <a:solidFill>
+                      <a:srgbClr val="1C7293"/>
+                    </a:solidFill>
+                  </a:tcPr>
+                </a:tc>
+                <a:tc>
+                  <a:txBody>
+                    <a:bodyPr/>
+                    <a:lstStyle/>
+                    <a:p>
+                      <a:pPr indent="0" lvl="0" marL="0" rtl="0" algn="l">
+                        <a:spcBef>
+                          <a:spcPts val="0"/>
+                        </a:spcBef>
+                        <a:spcAft>
+                          <a:spcPts val="0"/>
+                        </a:spcAft>
+                        <a:buNone/>
+                      </a:pPr>
+                      <a:r>
+                        <a:rPr b="1" lang="en-US" sz="2000">
+                          <a:solidFill>
+                            <a:schemeClr val="lt1"/>
+                          </a:solidFill>
+                          <a:latin typeface="Calibri"/>
+                          <a:ea typeface="Calibri"/>
+                          <a:cs typeface="Calibri"/>
+                          <a:sym typeface="Calibri"/>
+                        </a:rPr>
+                        <a:t>Responsibilities</a:t>
+                      </a:r>
+                      <a:endParaRPr b="1" sz="2000">
+                        <a:solidFill>
+                          <a:schemeClr val="lt1"/>
+                        </a:solidFill>
+                        <a:latin typeface="Calibri"/>
+                        <a:ea typeface="Calibri"/>
+                        <a:cs typeface="Calibri"/>
+                        <a:sym typeface="Calibri"/>
+                      </a:endParaRPr>
+                    </a:p>
+                  </a:txBody>
+                  <a:tcPr marT="91425" marB="91425" marR="91425" marL="91425">
+                    <a:solidFill>
+                      <a:srgbClr val="1C7293"/>
+                    </a:solidFill>
+                  </a:tcPr>
+                </a:tc>
+              </a:tr>
               <a:tr h="1140625">
                 <a:tc>
                   <a:txBody>
@@ -23030,12 +24047,24 @@
                       </a:pPr>
                       <a:r>
                         <a:rPr lang="en-US" sz="1800">
+                          <a:solidFill>
+                            <a:schemeClr val="dk1"/>
+                          </a:solidFill>
                           <a:latin typeface="Calibri"/>
                           <a:ea typeface="Calibri"/>
                           <a:cs typeface="Calibri"/>
                           <a:sym typeface="Calibri"/>
                         </a:rPr>
-                        <a:t>Nail &amp; Eye Pipelines + </a:t>
+                        <a:t>Palm &amp; Conjunctiva Pipelines</a:t>
+                      </a:r>
+                      <a:r>
+                        <a:rPr lang="en-US" sz="1800">
+                          <a:latin typeface="Calibri"/>
+                          <a:ea typeface="Calibri"/>
+                          <a:cs typeface="Calibri"/>
+                          <a:sym typeface="Calibri"/>
+                        </a:rPr>
+                        <a:t> + </a:t>
                       </a:r>
                       <a:r>
                         <a:rPr lang="en-US" sz="1800">
@@ -23078,12 +24107,15 @@
                       </a:pPr>
                       <a:r>
                         <a:rPr lang="en-US" sz="1800">
+                          <a:solidFill>
+                            <a:schemeClr val="dk1"/>
+                          </a:solidFill>
                           <a:latin typeface="Calibri"/>
                           <a:ea typeface="Calibri"/>
                           <a:cs typeface="Calibri"/>
                           <a:sym typeface="Calibri"/>
                         </a:rPr>
-                        <a:t>Pipeline for nails and eyes</a:t>
+                        <a:t>Full pipeline for palm and conjunctiva (data, encoder, evaluation)</a:t>
                       </a:r>
                       <a:r>
                         <a:rPr lang="en-US" sz="1800">
@@ -23092,7 +24124,7 @@
                           <a:cs typeface="Calibri"/>
                           <a:sym typeface="Calibri"/>
                         </a:rPr>
-                        <a:t>; </a:t>
+                        <a:t> </a:t>
                       </a:r>
                       <a:r>
                         <a:rPr lang="en-US" sz="1800">
@@ -23106,7 +24138,12 @@
                         </a:rPr>
                         <a:t>handles deployment</a:t>
                       </a:r>
-                      <a:endParaRPr/>
+                      <a:endParaRPr sz="1800">
+                        <a:latin typeface="Calibri"/>
+                        <a:ea typeface="Calibri"/>
+                        <a:cs typeface="Calibri"/>
+                        <a:sym typeface="Calibri"/>
+                      </a:endParaRPr>
                     </a:p>
                   </a:txBody>
                   <a:tcPr marT="91425" marB="91425" marR="91425" marL="91425"/>
@@ -23168,12 +24205,24 @@
                       </a:pPr>
                       <a:r>
                         <a:rPr lang="en-US" sz="1800">
+                          <a:solidFill>
+                            <a:schemeClr val="dk1"/>
+                          </a:solidFill>
                           <a:latin typeface="Calibri"/>
                           <a:ea typeface="Calibri"/>
                           <a:cs typeface="Calibri"/>
                           <a:sym typeface="Calibri"/>
                         </a:rPr>
-                        <a:t>Tongue &amp; Palm Pipelines +</a:t>
+                        <a:t>Tongue &amp; Fingernail Pipelines</a:t>
+                      </a:r>
+                      <a:r>
+                        <a:rPr lang="en-US" sz="1800">
+                          <a:latin typeface="Calibri"/>
+                          <a:ea typeface="Calibri"/>
+                          <a:cs typeface="Calibri"/>
+                          <a:sym typeface="Calibri"/>
+                        </a:rPr>
+                        <a:t> +</a:t>
                       </a:r>
                       <a:endParaRPr sz="1800">
                         <a:latin typeface="Calibri"/>
@@ -23241,17 +24290,13 @@
                         <a:spcAft>
                           <a:spcPts val="0"/>
                         </a:spcAft>
+                        <a:buClr>
+                          <a:schemeClr val="dk1"/>
+                        </a:buClr>
+                        <a:buSzPts val="1100"/>
+                        <a:buFont typeface="Arial"/>
                         <a:buNone/>
                       </a:pPr>
-                      <a:r>
-                        <a:rPr lang="en-US" sz="1800">
-                          <a:latin typeface="Calibri"/>
-                          <a:ea typeface="Calibri"/>
-                          <a:cs typeface="Calibri"/>
-                          <a:sym typeface="Calibri"/>
-                        </a:rPr>
-                        <a:t>Pipeline for tongue and palm; </a:t>
-                      </a:r>
                       <a:r>
                         <a:rPr lang="en-US" sz="1800">
                           <a:solidFill>
@@ -23262,19 +24307,33 @@
                           <a:cs typeface="Calibri"/>
                           <a:sym typeface="Calibri"/>
                         </a:rPr>
-                        <a:t>b</a:t>
+                        <a:t>Full pipeline for tongue and nail (data, encoder, evaluation); App development and app-to-model integration</a:t>
                       </a:r>
+                      <a:endParaRPr b="1" sz="1800">
+                        <a:solidFill>
+                          <a:schemeClr val="dk1"/>
+                        </a:solidFill>
+                        <a:latin typeface="Calibri"/>
+                        <a:ea typeface="Calibri"/>
+                        <a:cs typeface="Calibri"/>
+                        <a:sym typeface="Calibri"/>
+                      </a:endParaRPr>
+                    </a:p>
+                    <a:p>
+                      <a:pPr indent="0" lvl="0" marL="0" rtl="0" algn="l">
+                        <a:lnSpc>
+                          <a:spcPct val="150000"/>
+                        </a:lnSpc>
+                        <a:spcBef>
+                          <a:spcPts val="0"/>
+                        </a:spcBef>
+                        <a:spcAft>
+                          <a:spcPts val="0"/>
+                        </a:spcAft>
+                        <a:buNone/>
+                      </a:pPr>
                       <a:r>
-                        <a:rPr lang="en-US" sz="1800">
-                          <a:solidFill>
-                            <a:schemeClr val="dk1"/>
-                          </a:solidFill>
-                          <a:latin typeface="Calibri"/>
-                          <a:ea typeface="Calibri"/>
-                          <a:cs typeface="Calibri"/>
-                          <a:sym typeface="Calibri"/>
-                        </a:rPr>
-                        <a:t>uilds the UI</a:t>
+                        <a:t/>
                       </a:r>
                       <a:endParaRPr sz="1800">
                         <a:latin typeface="Calibri"/>
@@ -23997,7 +25056,7 @@
           </a:bodyPr>
           <a:lstStyle/>
           <a:p>
-            <a:pPr indent="0" lvl="0" marL="0" marR="0" rtl="0" algn="l">
+            <a:pPr indent="0" lvl="0" marL="0" marR="0" rtl="0" algn="just">
               <a:lnSpc>
                 <a:spcPct val="115000"/>
               </a:lnSpc>
@@ -24225,7 +25284,7 @@
           </a:bodyPr>
           <a:lstStyle/>
           <a:p>
-            <a:pPr indent="0" lvl="0" marL="0" marR="0" rtl="0" algn="l">
+            <a:pPr indent="0" lvl="0" marL="0" marR="0" rtl="0" algn="just">
               <a:lnSpc>
                 <a:spcPct val="115000"/>
               </a:lnSpc>
@@ -24405,7 +25464,7 @@
           </a:bodyPr>
           <a:lstStyle/>
           <a:p>
-            <a:pPr indent="0" lvl="0" marL="0" marR="0" rtl="0" algn="l">
+            <a:pPr indent="0" lvl="0" marL="0" marR="0" rtl="0" algn="just">
               <a:lnSpc>
                 <a:spcPct val="115000"/>
               </a:lnSpc>
@@ -25062,7 +26121,7 @@
             <a:tbl>
               <a:tblPr>
                 <a:noFill/>
-                <a:tableStyleId>{A86E29F2-8678-437A-8A81-A00D8066E49F}</a:tableStyleId>
+                <a:tableStyleId>{6DCBE433-D38A-414C-8CE7-A03D4E96D332}</a:tableStyleId>
               </a:tblPr>
               <a:tblGrid>
                 <a:gridCol w="2057400"/>
@@ -25992,7 +27051,7 @@
             <a:tbl>
               <a:tblPr>
                 <a:noFill/>
-                <a:tableStyleId>{A86E29F2-8678-437A-8A81-A00D8066E49F}</a:tableStyleId>
+                <a:tableStyleId>{6DCBE433-D38A-414C-8CE7-A03D4E96D332}</a:tableStyleId>
               </a:tblPr>
               <a:tblGrid>
                 <a:gridCol w="2057400"/>

</xml_diff>